<commit_message>
docs: reformule la douve Liaison (cartographie de toute la chaîne)
Liaison digitalise les vendeurs formels ET informels (importateur en gros →
détaillant) ; la douve = cartographie des acteurs + digitalisation de leurs
produits même hors ligne. Plan d'affaires + pitch deck.

Co-Authored-By: Claude Opus 4.8 (1M context) <noreply@anthropic.com>
</commit_message>
<xml_diff>
--- a/docs/pitch-deck-pieces-2026-06.pptx
+++ b/docs/pitch-deck-pieces-2026-06.pptx
@@ -3358,11 +3358,11 @@
             <a:pPr lvl="0"/>
             <a:r>
               <a:rPr b="1"/>
-              <a:t>Réseau Liaison</a:t>
-            </a:r>
-            <a:r>
-              <a:rPr/>
-              <a:t> (objectif 80 agents en 12 mois).</a:t>
+              <a:t>Cartographie de la chaîne + réseau Liaison</a:t>
+            </a:r>
+            <a:r>
+              <a:rPr/>
+              <a:t> — tous les acteurs (gros → détail, formels &amp; informels) et leurs produits digitalisés, même hors ligne (objectif 80 agents en 12 mois).</a:t>
             </a:r>
           </a:p>
           <a:p>
@@ -4607,7 +4607,15 @@
             </a:r>
             <a:r>
               <a:rPr/>
-              <a:t> — des agents terrain digitalisent les vendeurs informels, sans smartphone requis.</a:t>
+              <a:t> — des agents terrain digitalisent les vendeurs </a:t>
+            </a:r>
+            <a:r>
+              <a:rPr b="1"/>
+              <a:t>formels et informels</a:t>
+            </a:r>
+            <a:r>
+              <a:rPr/>
+              <a:t>, de l'importateur en gros au détaillant — même hors ligne.</a:t>
             </a:r>
           </a:p>
           <a:p>

</xml_diff>

<commit_message>
docs: cadre le problème sur l'empilement des marges d'intermédiaires
Tout intermédiaire (importateur→grossiste→détaillant→mécanicien) ajoute une
marge opaque ; Pièces rend la chaîne transparente et concurrentielle. Plan + deck.

Co-Authored-By: Claude Opus 4.8 (1M context) <noreply@anthropic.com>
</commit_message>
<xml_diff>
--- a/docs/pitch-deck-pieces-2026-06.pptx
+++ b/docs/pitch-deck-pieces-2026-06.pptx
@@ -4435,14 +4435,16 @@
             </a:r>
           </a:p>
           <a:p>
-            <a:pPr lvl="0"/>
+            <a:pPr lvl="0" indent="0" marL="0">
+              <a:buNone/>
+            </a:pPr>
             <a:r>
               <a:rPr b="1"/>
-              <a:t>Mécanicien</a:t>
-            </a:r>
-            <a:r>
-              <a:rPr/>
-              <a:t> : perd 2 à 4 h par pièce à faire le tour des cantines.</a:t>
+              <a:t>Chaque intermédiaire ajoute sa marge</a:t>
+            </a:r>
+            <a:r>
+              <a:rPr/>
+              <a:t> — importateur, grossiste, détaillant, mécanicien : l'acheteur paie l'accumulation, sans jamais voir le vrai prix.</a:t>
             </a:r>
           </a:p>
           <a:p>
@@ -4472,7 +4474,7 @@
             </a:r>
             <a:r>
               <a:rPr/>
-              <a:t> par véhicule immobilisé.</a:t>
+              <a:t> par véhicule immobilisé ; budget pièces opaque.</a:t>
             </a:r>
           </a:p>
           <a:p>
@@ -4483,7 +4485,7 @@
             </a:r>
             <a:r>
               <a:rPr/>
-              <a:t> : enfermé dans sa cantine, invisible en ligne.</a:t>
+              <a:t> : enfermé dans son comptoir, invisible en ligne.</a:t>
             </a:r>
           </a:p>
           <a:p>

</xml_diff>

<commit_message>
docs(pitch-deck): aligne le deck sur le plan d'affaires v1.3
Pre-seed ~1 M EUR (au lieu de Seed 1,5 M USD), next round Seed 4-6 M EUR,
take rate 10 %, paiement à la livraison, « largement informel »,
retrait de Gemini, perte flotte 25-50k F/jour. Rebuild PDF/DOCX/PPTX.

Co-Authored-By: Claude Opus 4.8 (1M context) <noreply@anthropic.com>
</commit_message>
<xml_diff>
--- a/docs/pitch-deck-pieces-2026-06.pptx
+++ b/docs/pitch-deck-pieces-2026-06.pptx
@@ -3380,7 +3380,7 @@
             <a:pPr lvl="0"/>
             <a:r>
               <a:rPr b="1"/>
-              <a:t>Escrow + garantie</a:t>
+              <a:t>Paiement à la livraison + garantie</a:t>
             </a:r>
             <a:r>
               <a:rPr/>
@@ -3919,15 +3919,15 @@
             </a:pPr>
             <a:r>
               <a:rPr sz="2000"/>
-              <a:t>Seed </a:t>
+              <a:t>Pre-seed </a:t>
             </a:r>
             <a:r>
               <a:rPr sz="2000" b="1"/>
-              <a:t>~1,5 M USD (≈ 900 M FCFA)</a:t>
+              <a:t>~1 M EUR (≈ 655 M FCFA)</a:t>
             </a:r>
             <a:r>
               <a:rPr sz="2000"/>
-              <a:t> — 20 à 24 mois de runway. Fourchette 1,2–1,8 M USD. Cohérent avec le marché 2025 (ticket Seed moyen ~1,6 M USD).</a:t>
+              <a:t> — 18 à 20 mois de runway. Fourchette 0,7–1,3 M EUR selon l'ambition de calendrier. Justifié par l'intensité capitalistique du modèle (ops terrain + stock tampon).</a:t>
             </a:r>
           </a:p>
           <a:p>
@@ -3944,7 +3944,7 @@
             </a:r>
             <a:r>
               <a:rPr b="1"/>
-              <a:t>Série A 4–7 M USD</a:t>
+              <a:t>Seed 4–6 M EUR</a:t>
             </a:r>
             <a:r>
               <a:rPr/>
@@ -4334,7 +4334,7 @@
             </a:pPr>
             <a:r>
               <a:rPr/>
-              <a:t>Pièces optimise les dépenses automobiles de tout le monde en Côte d'Ivoire — du propriétaire d'un véhicule au gestionnaire d'une flotte. Marketplace + flotte + réseau terrain, sur un marché de ~250 Mds FCFA/an, fragmenté et 100 % informel.</a:t>
+              <a:t>Pièces optimise les dépenses automobiles de tout le monde en Côte d'Ivoire — du propriétaire d'un véhicule au gestionnaire d'une flotte. Marketplace + flotte + réseau terrain, sur un marché de ~250 Mds FCFA/an, fragmenté et largement informel.</a:t>
             </a:r>
           </a:p>
           <a:p>
@@ -4351,7 +4351,7 @@
             </a:r>
             <a:r>
               <a:rPr sz="2000"/>
-              <a:t>, livrée et garantie. Seed ~1,5 M USD · Juin 2026 · Abidjan</a:t>
+              <a:t>, livrée et garantie. Pre-seed ~1 M EUR · Juin 2026 · Abidjan</a:t>
             </a:r>
           </a:p>
         </p:txBody>
@@ -4427,7 +4427,7 @@
             </a:r>
             <a:r>
               <a:rPr b="1"/>
-              <a:t>100 % informel</a:t>
+              <a:t>largement informel</a:t>
             </a:r>
             <a:r>
               <a:rPr/>
@@ -4470,7 +4470,7 @@
             </a:r>
             <a:r>
               <a:rPr b="1"/>
-              <a:t>30 000 à 50 000 F/jour</a:t>
+              <a:t>25 000 à 50 000 F/jour</a:t>
             </a:r>
             <a:r>
               <a:rPr/>
@@ -4579,15 +4579,15 @@
             </a:r>
             <a:r>
               <a:rPr/>
-              <a:t> — le mécanicien identifie, le propriétaire paie en </a:t>
+              <a:t> — le mécanicien identifie, le vendeur livre, le propriétaire </a:t>
             </a:r>
             <a:r>
               <a:rPr b="1"/>
-              <a:t>escrow Mobile Money</a:t>
-            </a:r>
-            <a:r>
-              <a:rPr/>
-              <a:t>, le vendeur livre. Prix et condition affichés, garantie, facture.</a:t>
+              <a:t>paie à la livraison</a:t>
+            </a:r>
+            <a:r>
+              <a:rPr/>
+              <a:t>. Prix et condition affichés, garantie, facture.</a:t>
             </a:r>
           </a:p>
           <a:p>
@@ -4708,7 +4708,7 @@
             </a:r>
             <a:r>
               <a:rPr b="1"/>
-              <a:t>escrow Mobile Money</a:t>
+              <a:t>paiement à la livraison</a:t>
             </a:r>
             <a:r>
               <a:rPr/>
@@ -4723,7 +4723,7 @@
             </a:r>
             <a:r>
               <a:rPr b="1"/>
-              <a:t>texte / photo IA (Gemini) / VIN</a:t>
+              <a:t>texte / photo IA / VIN</a:t>
             </a:r>
             <a:r>
               <a:rPr/>
@@ -4863,7 +4863,7 @@
             </a:r>
             <a:r>
               <a:rPr/>
-              <a:t>. À une take rate de 9–12 %, le SOM représente </a:t>
+              <a:t>. À une take rate de ~10 %, le SOM représente </a:t>
             </a:r>
             <a:r>
               <a:rPr b="1"/>
@@ -4871,7 +4871,7 @@
             </a:r>
             <a:r>
               <a:rPr/>
-              <a:t> (~6–10 M USD).</a:t>
+              <a:t>.</a:t>
             </a:r>
           </a:p>
         </p:txBody>
@@ -5139,7 +5139,7 @@
             </a:r>
             <a:r>
               <a:rPr/>
-              <a:t> (Orange Money, MTN, Wave) → l'escrow devient possible.</a:t>
+              <a:t> (Orange Money, MTN, Wave) → paiement à la livraison fiable et traçable.</a:t>
             </a:r>
           </a:p>
           <a:p>
@@ -5400,11 +5400,27 @@
             </a:r>
             <a:r>
               <a:rPr/>
-              <a:t> : revenu net </a:t>
+              <a:t> : panier moyen </a:t>
             </a:r>
             <a:r>
               <a:rPr b="1"/>
-              <a:t>2 560 F/commande</a:t>
+              <a:t>32 000 F</a:t>
+            </a:r>
+            <a:r>
+              <a:rPr/>
+              <a:t>, take rate </a:t>
+            </a:r>
+            <a:r>
+              <a:rPr b="1"/>
+              <a:t>10 %</a:t>
+            </a:r>
+            <a:r>
+              <a:rPr/>
+              <a:t> → </a:t>
+            </a:r>
+            <a:r>
+              <a:rPr b="1"/>
+              <a:t>3 200 F/commande</a:t>
             </a:r>
             <a:r>
               <a:rPr/>
@@ -5530,7 +5546,7 @@
                       </a:pPr>
                       <a:r>
                         <a:rPr/>
-                        <a:t>5–10 % côté vendeur</a:t>
+                        <a:t>7–15 %, au paiement</a:t>
                       </a:r>
                     </a:p>
                   </a:txBody>

</xml_diff>

<commit_message>
docs(pitch-deck): thème PPTX aux couleurs et polices Pièces
Ajoute un reference-doc pandoc (navy #00113A / orange #FF6B00,
Gloock titres + Instrument Sans corps) et le câble dans build.sh
pour tout slug pitch-deck*. Rebuild du .pptx.

Co-Authored-By: Claude Opus 4.8 (1M context) <noreply@anthropic.com>
</commit_message>
<xml_diff>
--- a/docs/pitch-deck-pieces-2026-06.pptx
+++ b/docs/pitch-deck-pieces-2026-06.pptx
@@ -5720,7 +5720,7 @@
 <file path=ppt/theme/theme1.xml><?xml version="1.0" encoding="utf-8"?>
 <a:theme xmlns:a="http://schemas.openxmlformats.org/drawingml/2006/main" name="Office Theme">
   <a:themeElements>
-    <a:clrScheme name="Office">
+    <a:clrScheme name="Pieces">
       <a:dk1>
         <a:sysClr val="windowText" lastClr="000000"/>
       </a:dk1>
@@ -5728,39 +5728,39 @@
         <a:sysClr val="window" lastClr="FFFFFF"/>
       </a:lt1>
       <a:dk2>
-        <a:srgbClr val="1F497D"/>
+        <a:srgbClr val="00113A"/>
       </a:dk2>
       <a:lt2>
-        <a:srgbClr val="EEECE1"/>
+        <a:srgbClr val="F5F5F4"/>
       </a:lt2>
       <a:accent1>
-        <a:srgbClr val="4F81BD"/>
+        <a:srgbClr val="FF6B00"/>
       </a:accent1>
       <a:accent2>
-        <a:srgbClr val="C0504D"/>
+        <a:srgbClr val="00113A"/>
       </a:accent2>
       <a:accent3>
-        <a:srgbClr val="9BBB59"/>
+        <a:srgbClr val="888888"/>
       </a:accent3>
       <a:accent4>
-        <a:srgbClr val="8064A2"/>
+        <a:srgbClr val="1A1A1A"/>
       </a:accent4>
       <a:accent5>
-        <a:srgbClr val="4BACC6"/>
+        <a:srgbClr val="FF8A33"/>
       </a:accent5>
       <a:accent6>
-        <a:srgbClr val="F79646"/>
+        <a:srgbClr val="00204F"/>
       </a:accent6>
       <a:hlink>
-        <a:srgbClr val="0000FF"/>
+        <a:srgbClr val="FF6B00"/>
       </a:hlink>
       <a:folHlink>
-        <a:srgbClr val="800080"/>
+        <a:srgbClr val="00113A"/>
       </a:folHlink>
     </a:clrScheme>
     <a:fontScheme name="Office">
       <a:majorFont>
-        <a:latin typeface="Calibri"/>
+        <a:latin typeface="Gloock"/>
         <a:ea typeface=""/>
         <a:cs typeface=""/>
         <a:font script="Jpan" typeface="ＭＳ Ｐゴシック"/>
@@ -5795,7 +5795,7 @@
         <a:font script="Geor" typeface="Sylfaen"/>
       </a:majorFont>
       <a:minorFont>
-        <a:latin typeface="Calibri"/>
+        <a:latin typeface="Instrument Sans"/>
         <a:ea typeface=""/>
         <a:cs typeface=""/>
         <a:font script="Jpan" typeface="ＭＳ Ｐゴシック"/>

</xml_diff>

<commit_message>
docs(pitch-deck): titres de slide en navy (PPTX)
Mappe le style de titre du master sur tx2 (dk2 = navy #00113A)
au lieu de tx1 (noir). Vérifié au rendu : titres navy serif,
en-têtes de tableau orange. Rebuild du .pptx.

Co-Authored-By: Claude Opus 4.8 (1M context) <noreply@anthropic.com>
</commit_message>
<xml_diff>
--- a/docs/pitch-deck-pieces-2026-06.pptx
+++ b/docs/pitch-deck-pieces-2026-06.pptx
@@ -1,6 +1,6 @@
 
 <file path=ppt/presentation.xml><?xml version="1.0" encoding="utf-8"?>
-<p:presentation xmlns:a="http://schemas.openxmlformats.org/drawingml/2006/main" xmlns:p="http://schemas.openxmlformats.org/presentationml/2006/main" xmlns:r="http://schemas.openxmlformats.org/officeDocument/2006/relationships" autoCompressPictures="0" saveSubsetFonts="1">
+<p:presentation xmlns:a="http://schemas.openxmlformats.org/drawingml/2006/main" xmlns:r="http://schemas.openxmlformats.org/officeDocument/2006/relationships" xmlns:p="http://schemas.openxmlformats.org/presentationml/2006/main" saveSubsetFonts="1" autoCompressPictures="0">
   <p:sldMasterIdLst>
     <p:sldMasterId id="2147483648" r:id="rId1"/>
   </p:sldMasterIdLst>
@@ -26,8 +26,8 @@
     <a:defPPr>
       <a:defRPr lang="en-US"/>
     </a:defPPr>
-    <a:lvl1pPr algn="l" defTabSz="457200" eaLnBrk="1" hangingPunct="1" latinLnBrk="0" marL="0" rtl="0">
-      <a:defRPr kern="1200" sz="1800">
+    <a:lvl1pPr marL="0" algn="l" defTabSz="457200" rtl="0" eaLnBrk="1" latinLnBrk="0" hangingPunct="1">
+      <a:defRPr sz="1800" kern="1200">
         <a:solidFill>
           <a:schemeClr val="tx1"/>
         </a:solidFill>
@@ -36,8 +36,8 @@
         <a:cs typeface="+mn-cs"/>
       </a:defRPr>
     </a:lvl1pPr>
-    <a:lvl2pPr algn="l" defTabSz="457200" eaLnBrk="1" hangingPunct="1" latinLnBrk="0" marL="457200" rtl="0">
-      <a:defRPr kern="1200" sz="1800">
+    <a:lvl2pPr marL="457200" algn="l" defTabSz="457200" rtl="0" eaLnBrk="1" latinLnBrk="0" hangingPunct="1">
+      <a:defRPr sz="1800" kern="1200">
         <a:solidFill>
           <a:schemeClr val="tx1"/>
         </a:solidFill>
@@ -46,8 +46,8 @@
         <a:cs typeface="+mn-cs"/>
       </a:defRPr>
     </a:lvl2pPr>
-    <a:lvl3pPr algn="l" defTabSz="457200" eaLnBrk="1" hangingPunct="1" latinLnBrk="0" marL="914400" rtl="0">
-      <a:defRPr kern="1200" sz="1800">
+    <a:lvl3pPr marL="914400" algn="l" defTabSz="457200" rtl="0" eaLnBrk="1" latinLnBrk="0" hangingPunct="1">
+      <a:defRPr sz="1800" kern="1200">
         <a:solidFill>
           <a:schemeClr val="tx1"/>
         </a:solidFill>
@@ -56,8 +56,8 @@
         <a:cs typeface="+mn-cs"/>
       </a:defRPr>
     </a:lvl3pPr>
-    <a:lvl4pPr algn="l" defTabSz="457200" eaLnBrk="1" hangingPunct="1" latinLnBrk="0" marL="1371600" rtl="0">
-      <a:defRPr kern="1200" sz="1800">
+    <a:lvl4pPr marL="1371600" algn="l" defTabSz="457200" rtl="0" eaLnBrk="1" latinLnBrk="0" hangingPunct="1">
+      <a:defRPr sz="1800" kern="1200">
         <a:solidFill>
           <a:schemeClr val="tx1"/>
         </a:solidFill>
@@ -66,8 +66,8 @@
         <a:cs typeface="+mn-cs"/>
       </a:defRPr>
     </a:lvl4pPr>
-    <a:lvl5pPr algn="l" defTabSz="457200" eaLnBrk="1" hangingPunct="1" latinLnBrk="0" marL="1828800" rtl="0">
-      <a:defRPr kern="1200" sz="1800">
+    <a:lvl5pPr marL="1828800" algn="l" defTabSz="457200" rtl="0" eaLnBrk="1" latinLnBrk="0" hangingPunct="1">
+      <a:defRPr sz="1800" kern="1200">
         <a:solidFill>
           <a:schemeClr val="tx1"/>
         </a:solidFill>
@@ -76,8 +76,8 @@
         <a:cs typeface="+mn-cs"/>
       </a:defRPr>
     </a:lvl5pPr>
-    <a:lvl6pPr algn="l" defTabSz="457200" eaLnBrk="1" hangingPunct="1" latinLnBrk="0" marL="2286000" rtl="0">
-      <a:defRPr kern="1200" sz="1800">
+    <a:lvl6pPr marL="2286000" algn="l" defTabSz="457200" rtl="0" eaLnBrk="1" latinLnBrk="0" hangingPunct="1">
+      <a:defRPr sz="1800" kern="1200">
         <a:solidFill>
           <a:schemeClr val="tx1"/>
         </a:solidFill>
@@ -86,8 +86,8 @@
         <a:cs typeface="+mn-cs"/>
       </a:defRPr>
     </a:lvl6pPr>
-    <a:lvl7pPr algn="l" defTabSz="457200" eaLnBrk="1" hangingPunct="1" latinLnBrk="0" marL="2743200" rtl="0">
-      <a:defRPr kern="1200" sz="1800">
+    <a:lvl7pPr marL="2743200" algn="l" defTabSz="457200" rtl="0" eaLnBrk="1" latinLnBrk="0" hangingPunct="1">
+      <a:defRPr sz="1800" kern="1200">
         <a:solidFill>
           <a:schemeClr val="tx1"/>
         </a:solidFill>
@@ -96,8 +96,8 @@
         <a:cs typeface="+mn-cs"/>
       </a:defRPr>
     </a:lvl7pPr>
-    <a:lvl8pPr algn="l" defTabSz="457200" eaLnBrk="1" hangingPunct="1" latinLnBrk="0" marL="3200400" rtl="0">
-      <a:defRPr kern="1200" sz="1800">
+    <a:lvl8pPr marL="3200400" algn="l" defTabSz="457200" rtl="0" eaLnBrk="1" latinLnBrk="0" hangingPunct="1">
+      <a:defRPr sz="1800" kern="1200">
         <a:solidFill>
           <a:schemeClr val="tx1"/>
         </a:solidFill>
@@ -106,8 +106,8 @@
         <a:cs typeface="+mn-cs"/>
       </a:defRPr>
     </a:lvl8pPr>
-    <a:lvl9pPr algn="l" defTabSz="457200" eaLnBrk="1" hangingPunct="1" latinLnBrk="0" marL="3657600" rtl="0">
-      <a:defRPr kern="1200" sz="1800">
+    <a:lvl9pPr marL="3657600" algn="l" defTabSz="457200" rtl="0" eaLnBrk="1" latinLnBrk="0" hangingPunct="1">
+      <a:defRPr sz="1800" kern="1200">
         <a:solidFill>
           <a:schemeClr val="tx1"/>
         </a:solidFill>
@@ -315,7 +315,7 @@
           <a:p>
             <a:fld id="{241EB5C9-1307-BA42-ABA2-0BC069CD8E7F}" type="datetimeFigureOut">
               <a:rPr lang="en-US" smtClean="0"/>
-              <a:t>1/2/22</a:t>
+              <a:t>6/7/26</a:t>
             </a:fld>
             <a:endParaRPr lang="en-US"/>
           </a:p>
@@ -357,7 +357,7 @@
           <a:p>
             <a:fld id="{C5EF2332-01BF-834F-8236-50238282D533}" type="slidenum">
               <a:rPr lang="en-US" smtClean="0"/>
-              <a:t>‹#›</a:t>
+              <a:t>‹N°›</a:t>
             </a:fld>
             <a:endParaRPr lang="en-US"/>
           </a:p>
@@ -483,7 +483,7 @@
           <a:p>
             <a:fld id="{241EB5C9-1307-BA42-ABA2-0BC069CD8E7F}" type="datetimeFigureOut">
               <a:rPr lang="en-US" smtClean="0"/>
-              <a:t>1/2/22</a:t>
+              <a:t>6/7/26</a:t>
             </a:fld>
             <a:endParaRPr lang="en-US"/>
           </a:p>
@@ -525,7 +525,7 @@
           <a:p>
             <a:fld id="{C5EF2332-01BF-834F-8236-50238282D533}" type="slidenum">
               <a:rPr lang="en-US" smtClean="0"/>
-              <a:t>‹#›</a:t>
+              <a:t>‹N°›</a:t>
             </a:fld>
             <a:endParaRPr lang="en-US"/>
           </a:p>
@@ -661,7 +661,7 @@
           <a:p>
             <a:fld id="{241EB5C9-1307-BA42-ABA2-0BC069CD8E7F}" type="datetimeFigureOut">
               <a:rPr lang="en-US" smtClean="0"/>
-              <a:t>1/2/22</a:t>
+              <a:t>6/7/26</a:t>
             </a:fld>
             <a:endParaRPr lang="en-US"/>
           </a:p>
@@ -703,7 +703,7 @@
           <a:p>
             <a:fld id="{C5EF2332-01BF-834F-8236-50238282D533}" type="slidenum">
               <a:rPr lang="en-US" smtClean="0"/>
-              <a:t>‹#›</a:t>
+              <a:t>‹N°›</a:t>
             </a:fld>
             <a:endParaRPr lang="en-US"/>
           </a:p>
@@ -829,7 +829,7 @@
           <a:p>
             <a:fld id="{241EB5C9-1307-BA42-ABA2-0BC069CD8E7F}" type="datetimeFigureOut">
               <a:rPr lang="en-US" smtClean="0"/>
-              <a:t>1/2/22</a:t>
+              <a:t>6/7/26</a:t>
             </a:fld>
             <a:endParaRPr lang="en-US"/>
           </a:p>
@@ -871,7 +871,7 @@
           <a:p>
             <a:fld id="{C5EF2332-01BF-834F-8236-50238282D533}" type="slidenum">
               <a:rPr lang="en-US" smtClean="0"/>
-              <a:t>‹#›</a:t>
+              <a:t>‹N°›</a:t>
             </a:fld>
             <a:endParaRPr lang="en-US"/>
           </a:p>
@@ -1074,7 +1074,7 @@
           <a:p>
             <a:fld id="{241EB5C9-1307-BA42-ABA2-0BC069CD8E7F}" type="datetimeFigureOut">
               <a:rPr lang="en-US" smtClean="0"/>
-              <a:t>1/2/22</a:t>
+              <a:t>6/7/26</a:t>
             </a:fld>
             <a:endParaRPr lang="en-US"/>
           </a:p>
@@ -1116,7 +1116,7 @@
           <a:p>
             <a:fld id="{C5EF2332-01BF-834F-8236-50238282D533}" type="slidenum">
               <a:rPr lang="en-US" smtClean="0"/>
-              <a:t>‹#›</a:t>
+              <a:t>‹N°›</a:t>
             </a:fld>
             <a:endParaRPr lang="en-US"/>
           </a:p>
@@ -1359,7 +1359,7 @@
           <a:p>
             <a:fld id="{241EB5C9-1307-BA42-ABA2-0BC069CD8E7F}" type="datetimeFigureOut">
               <a:rPr lang="en-US" smtClean="0"/>
-              <a:t>1/2/22</a:t>
+              <a:t>6/7/26</a:t>
             </a:fld>
             <a:endParaRPr lang="en-US"/>
           </a:p>
@@ -1401,7 +1401,7 @@
           <a:p>
             <a:fld id="{C5EF2332-01BF-834F-8236-50238282D533}" type="slidenum">
               <a:rPr lang="en-US" smtClean="0"/>
-              <a:t>‹#›</a:t>
+              <a:t>‹N°›</a:t>
             </a:fld>
             <a:endParaRPr lang="en-US"/>
           </a:p>
@@ -1778,7 +1778,7 @@
           <a:p>
             <a:fld id="{241EB5C9-1307-BA42-ABA2-0BC069CD8E7F}" type="datetimeFigureOut">
               <a:rPr lang="en-US" smtClean="0"/>
-              <a:t>1/2/22</a:t>
+              <a:t>6/7/26</a:t>
             </a:fld>
             <a:endParaRPr lang="en-US"/>
           </a:p>
@@ -1820,7 +1820,7 @@
           <a:p>
             <a:fld id="{C5EF2332-01BF-834F-8236-50238282D533}" type="slidenum">
               <a:rPr lang="en-US" smtClean="0"/>
-              <a:t>‹#›</a:t>
+              <a:t>‹N°›</a:t>
             </a:fld>
             <a:endParaRPr lang="en-US"/>
           </a:p>
@@ -1895,7 +1895,7 @@
           <a:p>
             <a:fld id="{241EB5C9-1307-BA42-ABA2-0BC069CD8E7F}" type="datetimeFigureOut">
               <a:rPr lang="en-US" smtClean="0"/>
-              <a:t>1/2/22</a:t>
+              <a:t>6/7/26</a:t>
             </a:fld>
             <a:endParaRPr lang="en-US"/>
           </a:p>
@@ -1937,7 +1937,7 @@
           <a:p>
             <a:fld id="{C5EF2332-01BF-834F-8236-50238282D533}" type="slidenum">
               <a:rPr lang="en-US" smtClean="0"/>
-              <a:t>‹#›</a:t>
+              <a:t>‹N°›</a:t>
             </a:fld>
             <a:endParaRPr lang="en-US"/>
           </a:p>
@@ -1990,7 +1990,7 @@
           <a:p>
             <a:fld id="{241EB5C9-1307-BA42-ABA2-0BC069CD8E7F}" type="datetimeFigureOut">
               <a:rPr lang="en-US" smtClean="0"/>
-              <a:t>1/2/22</a:t>
+              <a:t>6/7/26</a:t>
             </a:fld>
             <a:endParaRPr lang="en-US"/>
           </a:p>
@@ -2032,7 +2032,7 @@
           <a:p>
             <a:fld id="{C5EF2332-01BF-834F-8236-50238282D533}" type="slidenum">
               <a:rPr lang="en-US" smtClean="0"/>
-              <a:t>‹#›</a:t>
+              <a:t>‹N°›</a:t>
             </a:fld>
             <a:endParaRPr lang="en-US"/>
           </a:p>
@@ -2265,7 +2265,7 @@
           <a:p>
             <a:fld id="{241EB5C9-1307-BA42-ABA2-0BC069CD8E7F}" type="datetimeFigureOut">
               <a:rPr lang="en-US" smtClean="0"/>
-              <a:t>1/2/22</a:t>
+              <a:t>6/7/26</a:t>
             </a:fld>
             <a:endParaRPr lang="en-US"/>
           </a:p>
@@ -2307,7 +2307,7 @@
           <a:p>
             <a:fld id="{C5EF2332-01BF-834F-8236-50238282D533}" type="slidenum">
               <a:rPr lang="en-US" smtClean="0"/>
-              <a:t>‹#›</a:t>
+              <a:t>‹N°›</a:t>
             </a:fld>
             <a:endParaRPr lang="en-US"/>
           </a:p>
@@ -2517,7 +2517,7 @@
           <a:p>
             <a:fld id="{241EB5C9-1307-BA42-ABA2-0BC069CD8E7F}" type="datetimeFigureOut">
               <a:rPr lang="en-US" smtClean="0"/>
-              <a:t>1/2/22</a:t>
+              <a:t>6/7/26</a:t>
             </a:fld>
             <a:endParaRPr lang="en-US"/>
           </a:p>
@@ -2559,7 +2559,7 @@
           <a:p>
             <a:fld id="{C5EF2332-01BF-834F-8236-50238282D533}" type="slidenum">
               <a:rPr lang="en-US" smtClean="0"/>
-              <a:t>‹#›</a:t>
+              <a:t>‹N°›</a:t>
             </a:fld>
             <a:endParaRPr lang="en-US"/>
           </a:p>
@@ -2579,7 +2579,7 @@
 </file>
 
 <file path=ppt/slideMasters/slideMaster1.xml><?xml version="1.0" encoding="utf-8"?>
-<p:sldMaster xmlns:a="http://schemas.openxmlformats.org/drawingml/2006/main" xmlns:p="http://schemas.openxmlformats.org/presentationml/2006/main" xmlns:r="http://schemas.openxmlformats.org/officeDocument/2006/relationships">
+<p:sldMaster xmlns:a="http://schemas.openxmlformats.org/drawingml/2006/main" xmlns:r="http://schemas.openxmlformats.org/officeDocument/2006/relationships" xmlns:p="http://schemas.openxmlformats.org/presentationml/2006/main">
   <p:cSld>
     <p:bg>
       <p:bgRef idx="1001">
@@ -2620,7 +2620,7 @@
           </a:prstGeom>
         </p:spPr>
         <p:txBody>
-          <a:bodyPr anchor="ctr" bIns="45720" lIns="91440" rIns="91440" rtlCol="0" tIns="45720" vert="horz">
+          <a:bodyPr vert="horz" lIns="91440" tIns="45720" rIns="91440" bIns="45720" rtlCol="0" anchor="ctr">
             <a:normAutofit/>
           </a:bodyPr>
           <a:lstStyle/>
@@ -2639,7 +2639,7 @@
             <a:spLocks noGrp="1"/>
           </p:cNvSpPr>
           <p:nvPr>
-            <p:ph idx="1" type="body"/>
+            <p:ph type="body" idx="1"/>
           </p:nvPr>
         </p:nvSpPr>
         <p:spPr>
@@ -2652,7 +2652,7 @@
           </a:prstGeom>
         </p:spPr>
         <p:txBody>
-          <a:bodyPr bIns="45720" lIns="91440" rIns="91440" rtlCol="0" tIns="45720" vert="horz">
+          <a:bodyPr vert="horz" lIns="91440" tIns="45720" rIns="91440" bIns="45720" rtlCol="0">
             <a:normAutofit/>
           </a:bodyPr>
           <a:lstStyle/>
@@ -2700,7 +2700,7 @@
             <a:spLocks noGrp="1"/>
           </p:cNvSpPr>
           <p:nvPr>
-            <p:ph idx="2" sz="half" type="dt"/>
+            <p:ph type="dt" sz="half" idx="2"/>
           </p:nvPr>
         </p:nvSpPr>
         <p:spPr>
@@ -2713,7 +2713,7 @@
           </a:prstGeom>
         </p:spPr>
         <p:txBody>
-          <a:bodyPr anchor="ctr" bIns="45720" lIns="91440" rIns="91440" rtlCol="0" tIns="45720" vert="horz"/>
+          <a:bodyPr vert="horz" lIns="91440" tIns="45720" rIns="91440" bIns="45720" rtlCol="0" anchor="ctr"/>
           <a:lstStyle>
             <a:lvl1pPr algn="l">
               <a:defRPr sz="900">
@@ -2728,7 +2728,7 @@
           <a:p>
             <a:fld id="{241EB5C9-1307-BA42-ABA2-0BC069CD8E7F}" type="datetimeFigureOut">
               <a:rPr lang="en-US" smtClean="0"/>
-              <a:t>1/2/22</a:t>
+              <a:t>6/7/26</a:t>
             </a:fld>
             <a:endParaRPr lang="en-US"/>
           </a:p>
@@ -2741,7 +2741,7 @@
             <a:spLocks noGrp="1"/>
           </p:cNvSpPr>
           <p:nvPr>
-            <p:ph idx="3" sz="quarter" type="ftr"/>
+            <p:ph type="ftr" sz="quarter" idx="3"/>
           </p:nvPr>
         </p:nvSpPr>
         <p:spPr>
@@ -2754,7 +2754,7 @@
           </a:prstGeom>
         </p:spPr>
         <p:txBody>
-          <a:bodyPr anchor="ctr" bIns="45720" lIns="91440" rIns="91440" rtlCol="0" tIns="45720" vert="horz"/>
+          <a:bodyPr vert="horz" lIns="91440" tIns="45720" rIns="91440" bIns="45720" rtlCol="0" anchor="ctr"/>
           <a:lstStyle>
             <a:lvl1pPr algn="ctr">
               <a:defRPr sz="900">
@@ -2778,7 +2778,7 @@
             <a:spLocks noGrp="1"/>
           </p:cNvSpPr>
           <p:nvPr>
-            <p:ph idx="4" sz="quarter" type="sldNum"/>
+            <p:ph type="sldNum" sz="quarter" idx="4"/>
           </p:nvPr>
         </p:nvSpPr>
         <p:spPr>
@@ -2791,7 +2791,7 @@
           </a:prstGeom>
         </p:spPr>
         <p:txBody>
-          <a:bodyPr anchor="ctr" bIns="45720" lIns="91440" rIns="91440" rtlCol="0" tIns="45720" vert="horz"/>
+          <a:bodyPr vert="horz" lIns="91440" tIns="45720" rIns="91440" bIns="45720" rtlCol="0" anchor="ctr"/>
           <a:lstStyle>
             <a:lvl1pPr algn="r">
               <a:defRPr sz="900">
@@ -2806,7 +2806,7 @@
           <a:p>
             <a:fld id="{C5EF2332-01BF-834F-8236-50238282D533}" type="slidenum">
               <a:rPr lang="en-US" smtClean="0"/>
-              <a:t>‹#›</a:t>
+              <a:t>‹N°›</a:t>
             </a:fld>
             <a:endParaRPr lang="en-US"/>
           </a:p>
@@ -2819,7 +2819,7 @@
       </p:ext>
     </p:extLst>
   </p:cSld>
-  <p:clrMap accent1="accent1" accent2="accent2" accent3="accent3" accent4="accent4" accent5="accent5" accent6="accent6" bg1="lt1" bg2="lt2" folHlink="folHlink" hlink="hlink" tx1="dk1" tx2="dk2"/>
+  <p:clrMap bg1="lt1" tx1="dk1" bg2="lt2" tx2="dk2" accent1="accent1" accent2="accent2" accent3="accent3" accent4="accent4" accent5="accent5" accent6="accent6" hlink="hlink" folHlink="folHlink"/>
   <p:sldLayoutIdLst>
     <p:sldLayoutId id="2147483649" r:id="rId1"/>
     <p:sldLayoutId id="2147483650" r:id="rId2"/>
@@ -2835,12 +2835,12 @@
   </p:sldLayoutIdLst>
   <p:txStyles>
     <p:titleStyle>
-      <a:lvl1pPr algn="ctr" defTabSz="342900" eaLnBrk="1" hangingPunct="1" latinLnBrk="0" rtl="0">
+      <a:lvl1pPr algn="ctr" defTabSz="342900" rtl="0" eaLnBrk="1" latinLnBrk="0" hangingPunct="1">
         <a:spcBef>
           <a:spcPct val="0"/>
         </a:spcBef>
         <a:buNone/>
-        <a:defRPr kern="1200" sz="3300">
+        <a:defRPr sz="3300" kern="1200">
           <a:solidFill>
             <a:schemeClr val="tx2"/>
           </a:solidFill>
@@ -2851,13 +2851,13 @@
       </a:lvl1pPr>
     </p:titleStyle>
     <p:bodyStyle>
-      <a:lvl1pPr algn="l" defTabSz="342900" eaLnBrk="1" hangingPunct="1" indent="-342900" latinLnBrk="0" marL="342900" rtl="0">
+      <a:lvl1pPr marL="342900" indent="-342900" algn="l" defTabSz="342900" rtl="0" eaLnBrk="1" latinLnBrk="0" hangingPunct="1">
         <a:spcBef>
           <a:spcPct val="20000"/>
         </a:spcBef>
         <a:buFont typeface="Arial"/>
         <a:buChar char="•"/>
-        <a:defRPr kern="1200" sz="2400">
+        <a:defRPr sz="2400" kern="1200">
           <a:solidFill>
             <a:schemeClr val="tx1"/>
           </a:solidFill>
@@ -2866,13 +2866,13 @@
           <a:cs typeface="+mn-cs"/>
         </a:defRPr>
       </a:lvl1pPr>
-      <a:lvl2pPr algn="l" defTabSz="342900" eaLnBrk="1" hangingPunct="1" indent="-342900" latinLnBrk="0" marL="685800" rtl="0">
+      <a:lvl2pPr marL="685800" indent="-342900" algn="l" defTabSz="342900" rtl="0" eaLnBrk="1" latinLnBrk="0" hangingPunct="1">
         <a:spcBef>
           <a:spcPct val="20000"/>
         </a:spcBef>
         <a:buFont typeface="Arial"/>
         <a:buChar char="–"/>
-        <a:defRPr kern="1200" sz="2100">
+        <a:defRPr sz="2100" kern="1200">
           <a:solidFill>
             <a:schemeClr val="tx1"/>
           </a:solidFill>
@@ -2881,13 +2881,13 @@
           <a:cs typeface="+mn-cs"/>
         </a:defRPr>
       </a:lvl2pPr>
-      <a:lvl3pPr algn="l" defTabSz="342900" eaLnBrk="1" hangingPunct="1" indent="-342900" latinLnBrk="0" marL="1028700" rtl="0">
+      <a:lvl3pPr marL="1028700" indent="-342900" algn="l" defTabSz="342900" rtl="0" eaLnBrk="1" latinLnBrk="0" hangingPunct="1">
         <a:spcBef>
           <a:spcPct val="20000"/>
         </a:spcBef>
         <a:buFont typeface="Arial"/>
         <a:buChar char="•"/>
-        <a:defRPr kern="1200" sz="1800">
+        <a:defRPr sz="1800" kern="1200">
           <a:solidFill>
             <a:schemeClr val="tx1"/>
           </a:solidFill>
@@ -2896,13 +2896,13 @@
           <a:cs typeface="+mn-cs"/>
         </a:defRPr>
       </a:lvl3pPr>
-      <a:lvl4pPr algn="l" defTabSz="342900" eaLnBrk="1" hangingPunct="1" indent="-342900" latinLnBrk="0" marL="1371600" rtl="0">
+      <a:lvl4pPr marL="1371600" indent="-342900" algn="l" defTabSz="342900" rtl="0" eaLnBrk="1" latinLnBrk="0" hangingPunct="1">
         <a:spcBef>
           <a:spcPct val="20000"/>
         </a:spcBef>
         <a:buFont typeface="Arial"/>
         <a:buChar char="–"/>
-        <a:defRPr kern="1200" sz="1500">
+        <a:defRPr sz="1500" kern="1200">
           <a:solidFill>
             <a:schemeClr val="tx1"/>
           </a:solidFill>
@@ -2911,13 +2911,13 @@
           <a:cs typeface="+mn-cs"/>
         </a:defRPr>
       </a:lvl4pPr>
-      <a:lvl5pPr algn="l" defTabSz="342900" eaLnBrk="1" hangingPunct="1" indent="-342900" latinLnBrk="0" marL="1714500" rtl="0">
+      <a:lvl5pPr marL="1714500" indent="-342900" algn="l" defTabSz="342900" rtl="0" eaLnBrk="1" latinLnBrk="0" hangingPunct="1">
         <a:spcBef>
           <a:spcPct val="20000"/>
         </a:spcBef>
         <a:buFont typeface="Arial"/>
         <a:buChar char="»"/>
-        <a:defRPr kern="1200" sz="1500">
+        <a:defRPr sz="1500" kern="1200">
           <a:solidFill>
             <a:schemeClr val="tx1"/>
           </a:solidFill>
@@ -2926,13 +2926,13 @@
           <a:cs typeface="+mn-cs"/>
         </a:defRPr>
       </a:lvl5pPr>
-      <a:lvl6pPr algn="l" defTabSz="342900" eaLnBrk="1" hangingPunct="1" indent="-342900" latinLnBrk="0" marL="2057400" rtl="0">
+      <a:lvl6pPr marL="2057400" indent="-342900" algn="l" defTabSz="342900" rtl="0" eaLnBrk="1" latinLnBrk="0" hangingPunct="1">
         <a:spcBef>
           <a:spcPct val="20000"/>
         </a:spcBef>
         <a:buFont typeface="Arial"/>
         <a:buChar char="•"/>
-        <a:defRPr kern="1200" sz="1500">
+        <a:defRPr sz="1500" kern="1200">
           <a:solidFill>
             <a:schemeClr val="tx1"/>
           </a:solidFill>
@@ -2941,13 +2941,13 @@
           <a:cs typeface="+mn-cs"/>
         </a:defRPr>
       </a:lvl6pPr>
-      <a:lvl7pPr algn="l" defTabSz="342900" eaLnBrk="1" hangingPunct="1" indent="-342900" latinLnBrk="0" marL="2400300" rtl="0">
+      <a:lvl7pPr marL="2400300" indent="-342900" algn="l" defTabSz="342900" rtl="0" eaLnBrk="1" latinLnBrk="0" hangingPunct="1">
         <a:spcBef>
           <a:spcPct val="20000"/>
         </a:spcBef>
         <a:buFont typeface="Arial"/>
         <a:buChar char="•"/>
-        <a:defRPr kern="1200" sz="1500">
+        <a:defRPr sz="1500" kern="1200">
           <a:solidFill>
             <a:schemeClr val="tx1"/>
           </a:solidFill>
@@ -2956,13 +2956,13 @@
           <a:cs typeface="+mn-cs"/>
         </a:defRPr>
       </a:lvl7pPr>
-      <a:lvl8pPr algn="l" defTabSz="342900" eaLnBrk="1" hangingPunct="1" indent="-342900" latinLnBrk="0" marL="2743200" rtl="0">
+      <a:lvl8pPr marL="2743200" indent="-342900" algn="l" defTabSz="342900" rtl="0" eaLnBrk="1" latinLnBrk="0" hangingPunct="1">
         <a:spcBef>
           <a:spcPct val="20000"/>
         </a:spcBef>
         <a:buFont typeface="Arial"/>
         <a:buChar char="•"/>
-        <a:defRPr kern="1200" sz="1500">
+        <a:defRPr sz="1500" kern="1200">
           <a:solidFill>
             <a:schemeClr val="tx1"/>
           </a:solidFill>
@@ -2971,13 +2971,13 @@
           <a:cs typeface="+mn-cs"/>
         </a:defRPr>
       </a:lvl8pPr>
-      <a:lvl9pPr algn="l" defTabSz="342900" eaLnBrk="1" hangingPunct="1" indent="-342900" latinLnBrk="0" marL="3086100" rtl="0">
+      <a:lvl9pPr marL="3086100" indent="-342900" algn="l" defTabSz="342900" rtl="0" eaLnBrk="1" latinLnBrk="0" hangingPunct="1">
         <a:spcBef>
           <a:spcPct val="20000"/>
         </a:spcBef>
         <a:buFont typeface="Arial"/>
         <a:buChar char="•"/>
-        <a:defRPr kern="1200" sz="1500">
+        <a:defRPr sz="1500" kern="1200">
           <a:solidFill>
             <a:schemeClr val="tx1"/>
           </a:solidFill>
@@ -2991,8 +2991,8 @@
       <a:defPPr>
         <a:defRPr lang="en-US"/>
       </a:defPPr>
-      <a:lvl1pPr algn="l" defTabSz="342900" eaLnBrk="1" hangingPunct="1" latinLnBrk="0" marL="0" rtl="0">
-        <a:defRPr kern="1200" sz="1350">
+      <a:lvl1pPr marL="0" algn="l" defTabSz="342900" rtl="0" eaLnBrk="1" latinLnBrk="0" hangingPunct="1">
+        <a:defRPr sz="1350" kern="1200">
           <a:solidFill>
             <a:schemeClr val="tx1"/>
           </a:solidFill>
@@ -3001,8 +3001,8 @@
           <a:cs typeface="+mn-cs"/>
         </a:defRPr>
       </a:lvl1pPr>
-      <a:lvl2pPr algn="l" defTabSz="342900" eaLnBrk="1" hangingPunct="1" latinLnBrk="0" marL="342900" rtl="0">
-        <a:defRPr kern="1200" sz="1350">
+      <a:lvl2pPr marL="342900" algn="l" defTabSz="342900" rtl="0" eaLnBrk="1" latinLnBrk="0" hangingPunct="1">
+        <a:defRPr sz="1350" kern="1200">
           <a:solidFill>
             <a:schemeClr val="tx1"/>
           </a:solidFill>
@@ -3011,8 +3011,8 @@
           <a:cs typeface="+mn-cs"/>
         </a:defRPr>
       </a:lvl2pPr>
-      <a:lvl3pPr algn="l" defTabSz="342900" eaLnBrk="1" hangingPunct="1" latinLnBrk="0" marL="685800" rtl="0">
-        <a:defRPr kern="1200" sz="1350">
+      <a:lvl3pPr marL="685800" algn="l" defTabSz="342900" rtl="0" eaLnBrk="1" latinLnBrk="0" hangingPunct="1">
+        <a:defRPr sz="1350" kern="1200">
           <a:solidFill>
             <a:schemeClr val="tx1"/>
           </a:solidFill>
@@ -3021,8 +3021,8 @@
           <a:cs typeface="+mn-cs"/>
         </a:defRPr>
       </a:lvl3pPr>
-      <a:lvl4pPr algn="l" defTabSz="342900" eaLnBrk="1" hangingPunct="1" latinLnBrk="0" marL="1028700" rtl="0">
-        <a:defRPr kern="1200" sz="1350">
+      <a:lvl4pPr marL="1028700" algn="l" defTabSz="342900" rtl="0" eaLnBrk="1" latinLnBrk="0" hangingPunct="1">
+        <a:defRPr sz="1350" kern="1200">
           <a:solidFill>
             <a:schemeClr val="tx1"/>
           </a:solidFill>
@@ -3031,8 +3031,8 @@
           <a:cs typeface="+mn-cs"/>
         </a:defRPr>
       </a:lvl4pPr>
-      <a:lvl5pPr algn="l" defTabSz="342900" eaLnBrk="1" hangingPunct="1" latinLnBrk="0" marL="1371600" rtl="0">
-        <a:defRPr kern="1200" sz="1350">
+      <a:lvl5pPr marL="1371600" algn="l" defTabSz="342900" rtl="0" eaLnBrk="1" latinLnBrk="0" hangingPunct="1">
+        <a:defRPr sz="1350" kern="1200">
           <a:solidFill>
             <a:schemeClr val="tx1"/>
           </a:solidFill>
@@ -3041,8 +3041,8 @@
           <a:cs typeface="+mn-cs"/>
         </a:defRPr>
       </a:lvl5pPr>
-      <a:lvl6pPr algn="l" defTabSz="342900" eaLnBrk="1" hangingPunct="1" latinLnBrk="0" marL="1714500" rtl="0">
-        <a:defRPr kern="1200" sz="1350">
+      <a:lvl6pPr marL="1714500" algn="l" defTabSz="342900" rtl="0" eaLnBrk="1" latinLnBrk="0" hangingPunct="1">
+        <a:defRPr sz="1350" kern="1200">
           <a:solidFill>
             <a:schemeClr val="tx1"/>
           </a:solidFill>
@@ -3051,8 +3051,8 @@
           <a:cs typeface="+mn-cs"/>
         </a:defRPr>
       </a:lvl6pPr>
-      <a:lvl7pPr algn="l" defTabSz="342900" eaLnBrk="1" hangingPunct="1" latinLnBrk="0" marL="2057400" rtl="0">
-        <a:defRPr kern="1200" sz="1350">
+      <a:lvl7pPr marL="2057400" algn="l" defTabSz="342900" rtl="0" eaLnBrk="1" latinLnBrk="0" hangingPunct="1">
+        <a:defRPr sz="1350" kern="1200">
           <a:solidFill>
             <a:schemeClr val="tx1"/>
           </a:solidFill>
@@ -3061,8 +3061,8 @@
           <a:cs typeface="+mn-cs"/>
         </a:defRPr>
       </a:lvl7pPr>
-      <a:lvl8pPr algn="l" defTabSz="342900" eaLnBrk="1" hangingPunct="1" latinLnBrk="0" marL="2400300" rtl="0">
-        <a:defRPr kern="1200" sz="1350">
+      <a:lvl8pPr marL="2400300" algn="l" defTabSz="342900" rtl="0" eaLnBrk="1" latinLnBrk="0" hangingPunct="1">
+        <a:defRPr sz="1350" kern="1200">
           <a:solidFill>
             <a:schemeClr val="tx1"/>
           </a:solidFill>
@@ -3071,8 +3071,8 @@
           <a:cs typeface="+mn-cs"/>
         </a:defRPr>
       </a:lvl8pPr>
-      <a:lvl9pPr algn="l" defTabSz="342900" eaLnBrk="1" hangingPunct="1" latinLnBrk="0" marL="2743200" rtl="0">
-        <a:defRPr kern="1200" sz="1350">
+      <a:lvl9pPr marL="2743200" algn="l" defTabSz="342900" rtl="0" eaLnBrk="1" latinLnBrk="0" hangingPunct="1">
+        <a:defRPr sz="1350" kern="1200">
           <a:solidFill>
             <a:schemeClr val="tx1"/>
           </a:solidFill>
@@ -3103,38 +3103,41 @@
           <a:chExt cx="0" cy="0"/>
         </a:xfrm>
       </p:grpSpPr>
-      <p:sp>
-        <p:nvSpPr>
-          <p:cNvPr id="2" name="Title 1"/>
-          <p:cNvSpPr>
-            <a:spLocks noGrp="1"/>
-          </p:cNvSpPr>
-          <p:nvPr>
-            <p:ph type="title"/>
-          </p:nvPr>
-        </p:nvSpPr>
+      <p:pic>
+        <p:nvPicPr>
+          <p:cNvPr id="6" name="Image 5">
+            <a:extLst>
+              <a:ext uri="{FF2B5EF4-FFF2-40B4-BE49-F238E27FC236}">
+                <a16:creationId xmlns:a16="http://schemas.microsoft.com/office/drawing/2014/main" id="{FD901DC3-752B-B2F9-D766-1EF0DB2A7F11}"/>
+              </a:ext>
+            </a:extLst>
+          </p:cNvPr>
+          <p:cNvPicPr>
+            <a:picLocks noChangeAspect="1"/>
+          </p:cNvPicPr>
+          <p:nvPr/>
+        </p:nvPicPr>
+        <p:blipFill>
+          <a:blip r:embed="rId2"/>
+          <a:stretch>
+            <a:fillRect/>
+          </a:stretch>
+        </p:blipFill>
         <p:spPr>
           <a:xfrm>
-            <a:off x="722313" y="3305176"/>
-            <a:ext cx="7772400" cy="1021556"/>
+            <a:off x="388648" y="1968534"/>
+            <a:ext cx="2955758" cy="1206432"/>
           </a:xfrm>
+          <a:prstGeom prst="rect">
+            <a:avLst/>
+          </a:prstGeom>
         </p:spPr>
-        <p:txBody>
-          <a:bodyPr/>
-          <a:lstStyle/>
-          <a:p>
-            <a:pPr lvl="0" indent="0" marL="0">
-              <a:buNone/>
-            </a:pPr>
-            <a:r>
-              <a:rPr/>
-              <a:t>Pièces</a:t>
-            </a:r>
-          </a:p>
-        </p:txBody>
-      </p:sp>
+      </p:pic>
     </p:spTree>
   </p:cSld>
+  <p:clrMapOvr>
+    <a:masterClrMapping/>
+  </p:clrMapOvr>
 </p:sld>
 </file>
 
@@ -3170,11 +3173,10 @@
           <a:bodyPr/>
           <a:lstStyle/>
           <a:p>
-            <a:pPr lvl="0" indent="0" marL="0">
+            <a:pPr marL="0" lvl="0" indent="0">
               <a:buNone/>
             </a:pPr>
             <a:r>
-              <a:rPr/>
               <a:t>Go-to-market — 5 mouvements</a:t>
             </a:r>
           </a:p>
@@ -3192,7 +3194,9 @@
         </p:nvSpPr>
         <p:spPr/>
         <p:txBody>
-          <a:bodyPr/>
+          <a:bodyPr>
+            <a:normAutofit lnSpcReduction="10000"/>
+          </a:bodyPr>
           <a:lstStyle/>
           <a:p>
             <a:pPr lvl="0"/>
@@ -3201,7 +3205,6 @@
               <a:t>M0–6</a:t>
             </a:r>
             <a:r>
-              <a:rPr/>
               <a:t> : verrouiller Adjamé/Yopougon (20 Liaisons, 300 vendeurs, 350 commandes/jour).</a:t>
             </a:r>
           </a:p>
@@ -3212,7 +3215,6 @@
               <a:t>M3–12</a:t>
             </a:r>
             <a:r>
-              <a:rPr/>
               <a:t> : prendre le VTC (</a:t>
             </a:r>
             <a:r>
@@ -3220,7 +3222,6 @@
               <a:t>partenariat Yango</a:t>
             </a:r>
             <a:r>
-              <a:rPr/>
               <a:t>, flottes indépendantes, 3 cas clients -20 %).</a:t>
             </a:r>
           </a:p>
@@ -3231,7 +3232,6 @@
               <a:t>M6–15</a:t>
             </a:r>
             <a:r>
-              <a:rPr/>
               <a:t> : devenir le </a:t>
             </a:r>
             <a:r>
@@ -3239,7 +3239,6 @@
               <a:t>standard FNE-CI</a:t>
             </a:r>
             <a:r>
-              <a:rPr/>
               <a:t> (vente aux DAF : « récupérez votre TVA »).</a:t>
             </a:r>
           </a:p>
@@ -3250,7 +3249,6 @@
               <a:t>M12–18</a:t>
             </a:r>
             <a:r>
-              <a:rPr/>
               <a:t> : étendre BTP / transport collectif / corporate.</a:t>
             </a:r>
           </a:p>
@@ -3261,7 +3259,6 @@
               <a:t>M18–24</a:t>
             </a:r>
             <a:r>
-              <a:rPr/>
               <a:t> : sortir d'Abidjan (Bouaké, San Pedro) + pilote sous-régional.</a:t>
             </a:r>
           </a:p>
@@ -3269,6 +3266,9 @@
       </p:sp>
     </p:spTree>
   </p:cSld>
+  <p:clrMapOvr>
+    <a:masterClrMapping/>
+  </p:clrMapOvr>
 </p:sld>
 </file>
 
@@ -3304,11 +3304,10 @@
           <a:bodyPr/>
           <a:lstStyle/>
           <a:p>
-            <a:pPr lvl="0" indent="0" marL="0">
+            <a:pPr marL="0" lvl="0" indent="0">
               <a:buNone/>
             </a:pPr>
             <a:r>
-              <a:rPr/>
               <a:t>Concurrence &amp; douve</a:t>
             </a:r>
           </a:p>
@@ -3326,14 +3325,15 @@
         </p:nvSpPr>
         <p:spPr/>
         <p:txBody>
-          <a:bodyPr/>
-          <a:lstStyle/>
-          <a:p>
-            <a:pPr lvl="0" indent="0" marL="0">
+          <a:bodyPr>
+            <a:normAutofit fontScale="92500" lnSpcReduction="20000"/>
+          </a:bodyPr>
+          <a:lstStyle/>
+          <a:p>
+            <a:pPr marL="0" lvl="0" indent="0">
               <a:buNone/>
             </a:pPr>
             <a:r>
-              <a:rPr/>
               <a:t>Concurrent réel = </a:t>
             </a:r>
             <a:r>
@@ -3341,16 +3341,14 @@
               <a:t>magasins + WhatsApp + Excel</a:t>
             </a:r>
             <a:r>
-              <a:rPr/>
               <a:t>. Aucun acteur structuré à l'échelle nationale.</a:t>
             </a:r>
           </a:p>
           <a:p>
-            <a:pPr lvl="0" indent="0" marL="0">
+            <a:pPr marL="0" lvl="0" indent="0">
               <a:buNone/>
             </a:pPr>
             <a:r>
-              <a:rPr/>
               <a:t>Notre douve, défendable à 36 mois :</a:t>
             </a:r>
           </a:p>
@@ -3361,7 +3359,6 @@
               <a:t>Cartographie de la chaîne + réseau Liaison</a:t>
             </a:r>
             <a:r>
-              <a:rPr/>
               <a:t> — tous les acteurs (gros → détail, formels &amp; informels) et leurs produits digitalisés, même hors ligne (objectif 80 agents en 12 mois).</a:t>
             </a:r>
           </a:p>
@@ -3372,7 +3369,6 @@
               <a:t>Data fitments Côte d'Ivoire</a:t>
             </a:r>
             <a:r>
-              <a:rPr/>
               <a:t> — inattaquable à 100 000 transactions.</a:t>
             </a:r>
           </a:p>
@@ -3383,7 +3379,6 @@
               <a:t>Paiement à la livraison + garantie</a:t>
             </a:r>
             <a:r>
-              <a:rPr/>
               <a:t> — confiance dans un marché de méfiance.</a:t>
             </a:r>
           </a:p>
@@ -3394,7 +3389,6 @@
               <a:t>FNE-CI natif</a:t>
             </a:r>
             <a:r>
-              <a:rPr/>
               <a:t> — verrou réglementaire.</a:t>
             </a:r>
           </a:p>
@@ -3402,6 +3396,9 @@
       </p:sp>
     </p:spTree>
   </p:cSld>
+  <p:clrMapOvr>
+    <a:masterClrMapping/>
+  </p:clrMapOvr>
 </p:sld>
 </file>
 
@@ -3437,11 +3434,10 @@
           <a:bodyPr/>
           <a:lstStyle/>
           <a:p>
-            <a:pPr lvl="0" indent="0" marL="0">
+            <a:pPr marL="0" lvl="0" indent="0">
               <a:buNone/>
             </a:pPr>
             <a:r>
-              <a:rPr/>
               <a:t>Projections</a:t>
             </a:r>
           </a:p>
@@ -3459,7 +3455,7 @@
         </p:nvGraphicFramePr>
         <p:xfrm>
           <a:off x="457200" y="1193800"/>
-          <a:ext cx="8229600" cy="3390900"/>
+          <a:ext cx="8229600" cy="1783080"/>
         </p:xfrm>
         <a:graphic>
           <a:graphicData uri="http://schemas.openxmlformats.org/drawingml/2006/table">
@@ -3468,10 +3464,34 @@
                 <a:tableStyleId>{5C22544A-7EE6-4342-B048-85BDC9FD1C3A}</a:tableStyleId>
               </a:tblPr>
               <a:tblGrid>
-                <a:gridCol w="2057400"/>
-                <a:gridCol w="2057400"/>
-                <a:gridCol w="2057400"/>
-                <a:gridCol w="2057400"/>
+                <a:gridCol w="2057400">
+                  <a:extLst>
+                    <a:ext uri="{9D8B030D-6E8A-4147-A177-3AD203B41FA5}">
+                      <a16:colId xmlns:a16="http://schemas.microsoft.com/office/drawing/2014/main" val="20000"/>
+                    </a:ext>
+                  </a:extLst>
+                </a:gridCol>
+                <a:gridCol w="2057400">
+                  <a:extLst>
+                    <a:ext uri="{9D8B030D-6E8A-4147-A177-3AD203B41FA5}">
+                      <a16:colId xmlns:a16="http://schemas.microsoft.com/office/drawing/2014/main" val="20001"/>
+                    </a:ext>
+                  </a:extLst>
+                </a:gridCol>
+                <a:gridCol w="2057400">
+                  <a:extLst>
+                    <a:ext uri="{9D8B030D-6E8A-4147-A177-3AD203B41FA5}">
+                      <a16:colId xmlns:a16="http://schemas.microsoft.com/office/drawing/2014/main" val="20002"/>
+                    </a:ext>
+                  </a:extLst>
+                </a:gridCol>
+                <a:gridCol w="2057400">
+                  <a:extLst>
+                    <a:ext uri="{9D8B030D-6E8A-4147-A177-3AD203B41FA5}">
+                      <a16:colId xmlns:a16="http://schemas.microsoft.com/office/drawing/2014/main" val="20003"/>
+                    </a:ext>
+                  </a:extLst>
+                </a:gridCol>
               </a:tblGrid>
               <a:tr h="0">
                 <a:tc>
@@ -3489,11 +3509,10 @@
                     <a:bodyPr/>
                     <a:lstStyle/>
                     <a:p>
-                      <a:pPr lvl="0" indent="0" marL="0">
+                      <a:pPr marL="0" lvl="0" indent="0">
                         <a:buNone/>
                       </a:pPr>
                       <a:r>
-                        <a:rPr/>
                         <a:t>An 1</a:t>
                       </a:r>
                     </a:p>
@@ -3505,11 +3524,10 @@
                     <a:bodyPr/>
                     <a:lstStyle/>
                     <a:p>
-                      <a:pPr lvl="0" indent="0" marL="0">
+                      <a:pPr marL="0" lvl="0" indent="0">
                         <a:buNone/>
                       </a:pPr>
                       <a:r>
-                        <a:rPr/>
                         <a:t>An 2</a:t>
                       </a:r>
                     </a:p>
@@ -3521,17 +3539,21 @@
                     <a:bodyPr/>
                     <a:lstStyle/>
                     <a:p>
-                      <a:pPr lvl="0" indent="0" marL="0">
+                      <a:pPr marL="0" lvl="0" indent="0">
                         <a:buNone/>
                       </a:pPr>
                       <a:r>
-                        <a:rPr/>
                         <a:t>An 3</a:t>
                       </a:r>
                     </a:p>
                   </a:txBody>
                   <a:tcPr/>
                 </a:tc>
+                <a:extLst>
+                  <a:ext uri="{0D108BD9-81ED-4DB2-BD59-A6C34878D82A}">
+                    <a16:rowId xmlns:a16="http://schemas.microsoft.com/office/drawing/2014/main" val="10000"/>
+                  </a:ext>
+                </a:extLst>
               </a:tr>
               <a:tr h="0">
                 <a:tc>
@@ -3539,61 +3561,66 @@
                     <a:bodyPr/>
                     <a:lstStyle/>
                     <a:p>
-                      <a:pPr lvl="0" indent="0" marL="0">
+                      <a:pPr marL="0" lvl="0" indent="0">
                         <a:buNone/>
                       </a:pPr>
                       <a:r>
-                        <a:rPr/>
                         <a:t>Commandes/jour (fin)</a:t>
                       </a:r>
                     </a:p>
                   </a:txBody>
+                  <a:tcPr/>
                 </a:tc>
                 <a:tc>
                   <a:txBody>
                     <a:bodyPr/>
                     <a:lstStyle/>
                     <a:p>
-                      <a:pPr lvl="0" indent="0" marL="0">
+                      <a:pPr marL="0" lvl="0" indent="0">
                         <a:buNone/>
                       </a:pPr>
                       <a:r>
-                        <a:rPr/>
                         <a:t>600</a:t>
                       </a:r>
                     </a:p>
                   </a:txBody>
+                  <a:tcPr/>
                 </a:tc>
                 <a:tc>
                   <a:txBody>
                     <a:bodyPr/>
                     <a:lstStyle/>
                     <a:p>
-                      <a:pPr lvl="0" indent="0" marL="0">
+                      <a:pPr marL="0" lvl="0" indent="0">
                         <a:buNone/>
                       </a:pPr>
                       <a:r>
-                        <a:rPr/>
                         <a:t>1 500</a:t>
                       </a:r>
                     </a:p>
                   </a:txBody>
+                  <a:tcPr/>
                 </a:tc>
                 <a:tc>
                   <a:txBody>
                     <a:bodyPr/>
                     <a:lstStyle/>
                     <a:p>
-                      <a:pPr lvl="0" indent="0" marL="0">
+                      <a:pPr marL="0" lvl="0" indent="0">
                         <a:buNone/>
                       </a:pPr>
                       <a:r>
-                        <a:rPr/>
                         <a:t>2 800</a:t>
                       </a:r>
                     </a:p>
                   </a:txBody>
+                  <a:tcPr/>
                 </a:tc>
+                <a:extLst>
+                  <a:ext uri="{0D108BD9-81ED-4DB2-BD59-A6C34878D82A}">
+                    <a16:rowId xmlns:a16="http://schemas.microsoft.com/office/drawing/2014/main" val="10001"/>
+                  </a:ext>
+                </a:extLst>
               </a:tr>
               <a:tr h="0">
                 <a:tc>
@@ -3601,61 +3628,66 @@
                     <a:bodyPr/>
                     <a:lstStyle/>
                     <a:p>
-                      <a:pPr lvl="0" indent="0" marL="0">
+                      <a:pPr marL="0" lvl="0" indent="0">
                         <a:buNone/>
                       </a:pPr>
                       <a:r>
-                        <a:rPr/>
                         <a:t>Véhicules abonnés (fin)</a:t>
                       </a:r>
                     </a:p>
                   </a:txBody>
+                  <a:tcPr/>
                 </a:tc>
                 <a:tc>
                   <a:txBody>
                     <a:bodyPr/>
                     <a:lstStyle/>
                     <a:p>
-                      <a:pPr lvl="0" indent="0" marL="0">
+                      <a:pPr marL="0" lvl="0" indent="0">
                         <a:buNone/>
                       </a:pPr>
                       <a:r>
-                        <a:rPr/>
                         <a:t>1 500</a:t>
                       </a:r>
                     </a:p>
                   </a:txBody>
+                  <a:tcPr/>
                 </a:tc>
                 <a:tc>
                   <a:txBody>
                     <a:bodyPr/>
                     <a:lstStyle/>
                     <a:p>
-                      <a:pPr lvl="0" indent="0" marL="0">
+                      <a:pPr marL="0" lvl="0" indent="0">
                         <a:buNone/>
                       </a:pPr>
                       <a:r>
-                        <a:rPr/>
                         <a:t>4 000</a:t>
                       </a:r>
                     </a:p>
                   </a:txBody>
+                  <a:tcPr/>
                 </a:tc>
                 <a:tc>
                   <a:txBody>
                     <a:bodyPr/>
                     <a:lstStyle/>
                     <a:p>
-                      <a:pPr lvl="0" indent="0" marL="0">
+                      <a:pPr marL="0" lvl="0" indent="0">
                         <a:buNone/>
                       </a:pPr>
                       <a:r>
-                        <a:rPr/>
                         <a:t>8 000</a:t>
                       </a:r>
                     </a:p>
                   </a:txBody>
+                  <a:tcPr/>
                 </a:tc>
+                <a:extLst>
+                  <a:ext uri="{0D108BD9-81ED-4DB2-BD59-A6C34878D82A}">
+                    <a16:rowId xmlns:a16="http://schemas.microsoft.com/office/drawing/2014/main" val="10002"/>
+                  </a:ext>
+                </a:extLst>
               </a:tr>
               <a:tr h="0">
                 <a:tc>
@@ -3663,61 +3695,66 @@
                     <a:bodyPr/>
                     <a:lstStyle/>
                     <a:p>
-                      <a:pPr lvl="0" indent="0" marL="0">
+                      <a:pPr marL="0" lvl="0" indent="0">
                         <a:buNone/>
                       </a:pPr>
                       <a:r>
-                        <a:rPr/>
                         <a:t>GMV</a:t>
                       </a:r>
                     </a:p>
                   </a:txBody>
+                  <a:tcPr/>
                 </a:tc>
                 <a:tc>
                   <a:txBody>
                     <a:bodyPr/>
                     <a:lstStyle/>
                     <a:p>
-                      <a:pPr lvl="0" indent="0" marL="0">
+                      <a:pPr marL="0" lvl="0" indent="0">
                         <a:buNone/>
                       </a:pPr>
                       <a:r>
-                        <a:rPr/>
                         <a:t>~2,9 Mds F</a:t>
                       </a:r>
                     </a:p>
                   </a:txBody>
+                  <a:tcPr/>
                 </a:tc>
                 <a:tc>
                   <a:txBody>
                     <a:bodyPr/>
                     <a:lstStyle/>
                     <a:p>
-                      <a:pPr lvl="0" indent="0" marL="0">
+                      <a:pPr marL="0" lvl="0" indent="0">
                         <a:buNone/>
                       </a:pPr>
                       <a:r>
-                        <a:rPr/>
                         <a:t>~11,5 Mds F</a:t>
                       </a:r>
                     </a:p>
                   </a:txBody>
+                  <a:tcPr/>
                 </a:tc>
                 <a:tc>
                   <a:txBody>
                     <a:bodyPr/>
                     <a:lstStyle/>
                     <a:p>
-                      <a:pPr lvl="0" indent="0" marL="0">
+                      <a:pPr marL="0" lvl="0" indent="0">
                         <a:buNone/>
                       </a:pPr>
                       <a:r>
-                        <a:rPr/>
                         <a:t>~26 Mds F</a:t>
                       </a:r>
                     </a:p>
                   </a:txBody>
+                  <a:tcPr/>
                 </a:tc>
+                <a:extLst>
+                  <a:ext uri="{0D108BD9-81ED-4DB2-BD59-A6C34878D82A}">
+                    <a16:rowId xmlns:a16="http://schemas.microsoft.com/office/drawing/2014/main" val="10003"/>
+                  </a:ext>
+                </a:extLst>
               </a:tr>
               <a:tr h="0">
                 <a:tc>
@@ -3725,7 +3762,7 @@
                     <a:bodyPr/>
                     <a:lstStyle/>
                     <a:p>
-                      <a:pPr lvl="0" indent="0" marL="0">
+                      <a:pPr marL="0" lvl="0" indent="0">
                         <a:buNone/>
                       </a:pPr>
                       <a:r>
@@ -3734,13 +3771,14 @@
                       </a:r>
                     </a:p>
                   </a:txBody>
+                  <a:tcPr/>
                 </a:tc>
                 <a:tc>
                   <a:txBody>
                     <a:bodyPr/>
                     <a:lstStyle/>
                     <a:p>
-                      <a:pPr lvl="0" indent="0" marL="0">
+                      <a:pPr marL="0" lvl="0" indent="0">
                         <a:buNone/>
                       </a:pPr>
                       <a:r>
@@ -3749,13 +3787,14 @@
                       </a:r>
                     </a:p>
                   </a:txBody>
+                  <a:tcPr/>
                 </a:tc>
                 <a:tc>
                   <a:txBody>
                     <a:bodyPr/>
                     <a:lstStyle/>
                     <a:p>
-                      <a:pPr lvl="0" indent="0" marL="0">
+                      <a:pPr marL="0" lvl="0" indent="0">
                         <a:buNone/>
                       </a:pPr>
                       <a:r>
@@ -3764,13 +3803,14 @@
                       </a:r>
                     </a:p>
                   </a:txBody>
+                  <a:tcPr/>
                 </a:tc>
                 <a:tc>
                   <a:txBody>
                     <a:bodyPr/>
                     <a:lstStyle/>
                     <a:p>
-                      <a:pPr lvl="0" indent="0" marL="0">
+                      <a:pPr marL="0" lvl="0" indent="0">
                         <a:buNone/>
                       </a:pPr>
                       <a:r>
@@ -3779,7 +3819,13 @@
                       </a:r>
                     </a:p>
                   </a:txBody>
+                  <a:tcPr/>
                 </a:tc>
+                <a:extLst>
+                  <a:ext uri="{0D108BD9-81ED-4DB2-BD59-A6C34878D82A}">
+                    <a16:rowId xmlns:a16="http://schemas.microsoft.com/office/drawing/2014/main" val="10004"/>
+                  </a:ext>
+                </a:extLst>
               </a:tr>
               <a:tr h="0">
                 <a:tc>
@@ -3787,61 +3833,66 @@
                     <a:bodyPr/>
                     <a:lstStyle/>
                     <a:p>
-                      <a:pPr lvl="0" indent="0" marL="0">
+                      <a:pPr marL="0" lvl="0" indent="0">
                         <a:buNone/>
                       </a:pPr>
                       <a:r>
-                        <a:rPr/>
                         <a:t>EBITDA</a:t>
                       </a:r>
                     </a:p>
                   </a:txBody>
+                  <a:tcPr/>
                 </a:tc>
                 <a:tc>
                   <a:txBody>
                     <a:bodyPr/>
                     <a:lstStyle/>
                     <a:p>
-                      <a:pPr lvl="0" indent="0" marL="0">
+                      <a:pPr marL="0" lvl="0" indent="0">
                         <a:buNone/>
                       </a:pPr>
                       <a:r>
-                        <a:rPr/>
                         <a:t>négatif</a:t>
                       </a:r>
                     </a:p>
                   </a:txBody>
+                  <a:tcPr/>
                 </a:tc>
                 <a:tc>
                   <a:txBody>
                     <a:bodyPr/>
                     <a:lstStyle/>
                     <a:p>
-                      <a:pPr lvl="0" indent="0" marL="0">
+                      <a:pPr marL="0" lvl="0" indent="0">
                         <a:buNone/>
                       </a:pPr>
                       <a:r>
-                        <a:rPr/>
                         <a:t>≈ break-even</a:t>
                       </a:r>
                     </a:p>
                   </a:txBody>
+                  <a:tcPr/>
                 </a:tc>
                 <a:tc>
                   <a:txBody>
                     <a:bodyPr/>
                     <a:lstStyle/>
                     <a:p>
-                      <a:pPr lvl="0" indent="0" marL="0">
+                      <a:pPr marL="0" lvl="0" indent="0">
                         <a:buNone/>
                       </a:pPr>
                       <a:r>
-                        <a:rPr/>
                         <a:t>positif</a:t>
                       </a:r>
                     </a:p>
                   </a:txBody>
+                  <a:tcPr/>
                 </a:tc>
+                <a:extLst>
+                  <a:ext uri="{0D108BD9-81ED-4DB2-BD59-A6C34878D82A}">
+                    <a16:rowId xmlns:a16="http://schemas.microsoft.com/office/drawing/2014/main" val="10005"/>
+                  </a:ext>
+                </a:extLst>
               </a:tr>
             </a:tbl>
           </a:graphicData>
@@ -3849,6 +3900,9 @@
       </p:graphicFrame>
     </p:spTree>
   </p:cSld>
+  <p:clrMapOvr>
+    <a:masterClrMapping/>
+  </p:clrMapOvr>
 </p:sld>
 </file>
 
@@ -3889,11 +3943,10 @@
           <a:bodyPr/>
           <a:lstStyle/>
           <a:p>
-            <a:pPr lvl="0" indent="0" marL="0">
+            <a:pPr marL="0" lvl="0" indent="0">
               <a:buNone/>
             </a:pPr>
             <a:r>
-              <a:rPr/>
               <a:t>La demande</a:t>
             </a:r>
           </a:p>
@@ -3906,15 +3959,17 @@
             <a:spLocks noGrp="1"/>
           </p:cNvSpPr>
           <p:nvPr>
-            <p:ph idx="2" sz="half" type="body"/>
+            <p:ph type="body" sz="half" idx="2"/>
           </p:nvPr>
         </p:nvSpPr>
         <p:spPr/>
         <p:txBody>
-          <a:bodyPr/>
-          <a:lstStyle/>
-          <a:p>
-            <a:pPr lvl="0" indent="0" marL="1270000">
+          <a:bodyPr>
+            <a:normAutofit fontScale="85000" lnSpcReduction="20000"/>
+          </a:bodyPr>
+          <a:lstStyle/>
+          <a:p>
+            <a:pPr marL="1270000" lvl="0" indent="0">
               <a:buNone/>
             </a:pPr>
             <a:r>
@@ -3931,7 +3986,7 @@
             </a:r>
           </a:p>
           <a:p>
-            <a:pPr lvl="0" indent="0" marL="0">
+            <a:pPr marL="0" lvl="0" indent="0">
               <a:buNone/>
             </a:pPr>
             <a:r>
@@ -3939,7 +3994,6 @@
               <a:t>Jalons débloqués</a:t>
             </a:r>
             <a:r>
-              <a:rPr/>
               <a:t> : 1 500 véhicules abonnés, 600 commandes/jour, GMV &gt; 250 M F/mois, break-even Abidjan à M18 → </a:t>
             </a:r>
             <a:r>
@@ -3947,7 +4001,6 @@
               <a:t>Seed 4–6 M EUR</a:t>
             </a:r>
             <a:r>
-              <a:rPr/>
               <a:t>.</a:t>
             </a:r>
           </a:p>
@@ -3965,7 +4018,7 @@
         </p:nvGraphicFramePr>
         <p:xfrm>
           <a:off x="3568700" y="203200"/>
-          <a:ext cx="5105400" cy="4381500"/>
+          <a:ext cx="5105400" cy="1988820"/>
         </p:xfrm>
         <a:graphic>
           <a:graphicData uri="http://schemas.openxmlformats.org/drawingml/2006/table">
@@ -3974,8 +4027,20 @@
                 <a:tableStyleId>{5C22544A-7EE6-4342-B048-85BDC9FD1C3A}</a:tableStyleId>
               </a:tblPr>
               <a:tblGrid>
-                <a:gridCol w="2552700"/>
-                <a:gridCol w="2552700"/>
+                <a:gridCol w="2552700">
+                  <a:extLst>
+                    <a:ext uri="{9D8B030D-6E8A-4147-A177-3AD203B41FA5}">
+                      <a16:colId xmlns:a16="http://schemas.microsoft.com/office/drawing/2014/main" val="20000"/>
+                    </a:ext>
+                  </a:extLst>
+                </a:gridCol>
+                <a:gridCol w="2552700">
+                  <a:extLst>
+                    <a:ext uri="{9D8B030D-6E8A-4147-A177-3AD203B41FA5}">
+                      <a16:colId xmlns:a16="http://schemas.microsoft.com/office/drawing/2014/main" val="20001"/>
+                    </a:ext>
+                  </a:extLst>
+                </a:gridCol>
               </a:tblGrid>
               <a:tr h="0">
                 <a:tc>
@@ -3983,11 +4048,10 @@
                     <a:bodyPr/>
                     <a:lstStyle/>
                     <a:p>
-                      <a:pPr lvl="0" indent="0" marL="0">
+                      <a:pPr marL="0" lvl="0" indent="0">
                         <a:buNone/>
                       </a:pPr>
                       <a:r>
-                        <a:rPr/>
                         <a:t>Emploi des fonds</a:t>
                       </a:r>
                     </a:p>
@@ -3999,17 +4063,21 @@
                     <a:bodyPr/>
                     <a:lstStyle/>
                     <a:p>
-                      <a:pPr lvl="0" indent="0" marL="0">
+                      <a:pPr marL="0" lvl="0" indent="0">
                         <a:buNone/>
                       </a:pPr>
                       <a:r>
-                        <a:rPr/>
                         <a:t>Part</a:t>
                       </a:r>
                     </a:p>
                   </a:txBody>
                   <a:tcPr/>
                 </a:tc>
+                <a:extLst>
+                  <a:ext uri="{0D108BD9-81ED-4DB2-BD59-A6C34878D82A}">
+                    <a16:rowId xmlns:a16="http://schemas.microsoft.com/office/drawing/2014/main" val="10000"/>
+                  </a:ext>
+                </a:extLst>
               </a:tr>
               <a:tr h="0">
                 <a:tc>
@@ -4017,31 +4085,36 @@
                     <a:bodyPr/>
                     <a:lstStyle/>
                     <a:p>
-                      <a:pPr lvl="0" indent="0" marL="0">
+                      <a:pPr marL="0" lvl="0" indent="0">
                         <a:buNone/>
                       </a:pPr>
                       <a:r>
-                        <a:rPr/>
                         <a:t>Liaison &amp; opérations terrain</a:t>
                       </a:r>
                     </a:p>
                   </a:txBody>
+                  <a:tcPr/>
                 </a:tc>
                 <a:tc>
                   <a:txBody>
                     <a:bodyPr/>
                     <a:lstStyle/>
                     <a:p>
-                      <a:pPr lvl="0" indent="0" marL="0">
+                      <a:pPr marL="0" lvl="0" indent="0">
                         <a:buNone/>
                       </a:pPr>
                       <a:r>
-                        <a:rPr/>
                         <a:t>30 %</a:t>
                       </a:r>
                     </a:p>
                   </a:txBody>
+                  <a:tcPr/>
                 </a:tc>
+                <a:extLst>
+                  <a:ext uri="{0D108BD9-81ED-4DB2-BD59-A6C34878D82A}">
+                    <a16:rowId xmlns:a16="http://schemas.microsoft.com/office/drawing/2014/main" val="10001"/>
+                  </a:ext>
+                </a:extLst>
               </a:tr>
               <a:tr h="0">
                 <a:tc>
@@ -4049,31 +4122,36 @@
                     <a:bodyPr/>
                     <a:lstStyle/>
                     <a:p>
-                      <a:pPr lvl="0" indent="0" marL="0">
+                      <a:pPr marL="0" lvl="0" indent="0">
                         <a:buNone/>
                       </a:pPr>
                       <a:r>
-                        <a:rPr/>
                         <a:t>Commercial &amp; GTM</a:t>
                       </a:r>
                     </a:p>
                   </a:txBody>
+                  <a:tcPr/>
                 </a:tc>
                 <a:tc>
                   <a:txBody>
                     <a:bodyPr/>
                     <a:lstStyle/>
                     <a:p>
-                      <a:pPr lvl="0" indent="0" marL="0">
+                      <a:pPr marL="0" lvl="0" indent="0">
                         <a:buNone/>
                       </a:pPr>
                       <a:r>
-                        <a:rPr/>
                         <a:t>25 %</a:t>
                       </a:r>
                     </a:p>
                   </a:txBody>
+                  <a:tcPr/>
                 </a:tc>
+                <a:extLst>
+                  <a:ext uri="{0D108BD9-81ED-4DB2-BD59-A6C34878D82A}">
+                    <a16:rowId xmlns:a16="http://schemas.microsoft.com/office/drawing/2014/main" val="10002"/>
+                  </a:ext>
+                </a:extLst>
               </a:tr>
               <a:tr h="0">
                 <a:tc>
@@ -4081,31 +4159,36 @@
                     <a:bodyPr/>
                     <a:lstStyle/>
                     <a:p>
-                      <a:pPr lvl="0" indent="0" marL="0">
+                      <a:pPr marL="0" lvl="0" indent="0">
                         <a:buNone/>
                       </a:pPr>
                       <a:r>
-                        <a:rPr/>
                         <a:t>Produit &amp; tech</a:t>
                       </a:r>
                     </a:p>
                   </a:txBody>
+                  <a:tcPr/>
                 </a:tc>
                 <a:tc>
                   <a:txBody>
                     <a:bodyPr/>
                     <a:lstStyle/>
                     <a:p>
-                      <a:pPr lvl="0" indent="0" marL="0">
+                      <a:pPr marL="0" lvl="0" indent="0">
                         <a:buNone/>
                       </a:pPr>
                       <a:r>
-                        <a:rPr/>
                         <a:t>25 %</a:t>
                       </a:r>
                     </a:p>
                   </a:txBody>
+                  <a:tcPr/>
                 </a:tc>
+                <a:extLst>
+                  <a:ext uri="{0D108BD9-81ED-4DB2-BD59-A6C34878D82A}">
+                    <a16:rowId xmlns:a16="http://schemas.microsoft.com/office/drawing/2014/main" val="10003"/>
+                  </a:ext>
+                </a:extLst>
               </a:tr>
               <a:tr h="0">
                 <a:tc>
@@ -4113,31 +4196,36 @@
                     <a:bodyPr/>
                     <a:lstStyle/>
                     <a:p>
-                      <a:pPr lvl="0" indent="0" marL="0">
+                      <a:pPr marL="0" lvl="0" indent="0">
                         <a:buNone/>
                       </a:pPr>
                       <a:r>
-                        <a:rPr/>
                         <a:t>G&amp;A, finance, conformité</a:t>
                       </a:r>
                     </a:p>
                   </a:txBody>
+                  <a:tcPr/>
                 </a:tc>
                 <a:tc>
                   <a:txBody>
                     <a:bodyPr/>
                     <a:lstStyle/>
                     <a:p>
-                      <a:pPr lvl="0" indent="0" marL="0">
+                      <a:pPr marL="0" lvl="0" indent="0">
                         <a:buNone/>
                       </a:pPr>
                       <a:r>
-                        <a:rPr/>
                         <a:t>10 %</a:t>
                       </a:r>
                     </a:p>
                   </a:txBody>
+                  <a:tcPr/>
                 </a:tc>
+                <a:extLst>
+                  <a:ext uri="{0D108BD9-81ED-4DB2-BD59-A6C34878D82A}">
+                    <a16:rowId xmlns:a16="http://schemas.microsoft.com/office/drawing/2014/main" val="10004"/>
+                  </a:ext>
+                </a:extLst>
               </a:tr>
               <a:tr h="0">
                 <a:tc>
@@ -4145,31 +4233,36 @@
                     <a:bodyPr/>
                     <a:lstStyle/>
                     <a:p>
-                      <a:pPr lvl="0" indent="0" marL="0">
+                      <a:pPr marL="0" lvl="0" indent="0">
                         <a:buNone/>
                       </a:pPr>
                       <a:r>
-                        <a:rPr/>
                         <a:t>Fonds de roulement &amp; contingence</a:t>
                       </a:r>
                     </a:p>
                   </a:txBody>
+                  <a:tcPr/>
                 </a:tc>
                 <a:tc>
                   <a:txBody>
                     <a:bodyPr/>
                     <a:lstStyle/>
                     <a:p>
-                      <a:pPr lvl="0" indent="0" marL="0">
+                      <a:pPr marL="0" lvl="0" indent="0">
                         <a:buNone/>
                       </a:pPr>
                       <a:r>
-                        <a:rPr/>
                         <a:t>10 %</a:t>
                       </a:r>
                     </a:p>
                   </a:txBody>
+                  <a:tcPr/>
                 </a:tc>
+                <a:extLst>
+                  <a:ext uri="{0D108BD9-81ED-4DB2-BD59-A6C34878D82A}">
+                    <a16:rowId xmlns:a16="http://schemas.microsoft.com/office/drawing/2014/main" val="10005"/>
+                  </a:ext>
+                </a:extLst>
               </a:tr>
             </a:tbl>
           </a:graphicData>
@@ -4177,6 +4270,9 @@
       </p:graphicFrame>
     </p:spTree>
   </p:cSld>
+  <p:clrMapOvr>
+    <a:masterClrMapping/>
+  </p:clrMapOvr>
 </p:sld>
 </file>
 
@@ -4212,11 +4308,10 @@
           <a:bodyPr/>
           <a:lstStyle/>
           <a:p>
-            <a:pPr lvl="0" indent="0" marL="0">
+            <a:pPr marL="0" lvl="0" indent="0">
               <a:buNone/>
             </a:pPr>
             <a:r>
-              <a:rPr/>
               <a:t>Vision</a:t>
             </a:r>
           </a:p>
@@ -4237,7 +4332,7 @@
           <a:bodyPr/>
           <a:lstStyle/>
           <a:p>
-            <a:pPr lvl="0" indent="0" marL="1270000">
+            <a:pPr marL="1270000" lvl="0" indent="0">
               <a:buNone/>
             </a:pPr>
             <a:r>
@@ -4254,16 +4349,15 @@
             </a:r>
           </a:p>
           <a:p>
-            <a:pPr lvl="0" indent="0" marL="0">
+            <a:pPr marL="0" lvl="0" indent="0">
               <a:buNone/>
             </a:pPr>
             <a:r>
-              <a:rPr/>
               <a:t>Abidjan d'abord. Puis la Côte d'Ivoire. Puis Dakar, Cotonou, et la sous-région — même modèle, même Mobile Money, même parc.</a:t>
             </a:r>
           </a:p>
           <a:p>
-            <a:pPr lvl="0" indent="0" marL="0">
+            <a:pPr marL="0" lvl="0" indent="0">
               <a:buNone/>
             </a:pPr>
             <a:r>
@@ -4272,7 +4366,7 @@
             </a:r>
           </a:p>
           <a:p>
-            <a:pPr lvl="0" indent="0" marL="0">
+            <a:pPr marL="0" lvl="0" indent="0">
               <a:buNone/>
             </a:pPr>
             <a:r>
@@ -4294,6 +4388,9 @@
       </p:sp>
     </p:spTree>
   </p:cSld>
+  <p:clrMapOvr>
+    <a:masterClrMapping/>
+  </p:clrMapOvr>
 </p:sld>
 </file>
 
@@ -4329,35 +4426,220 @@
           <a:bodyPr/>
           <a:lstStyle/>
           <a:p>
-            <a:pPr lvl="0" indent="0" marL="0">
+            <a:pPr marL="0" lvl="0" indent="0">
               <a:buNone/>
             </a:pPr>
             <a:r>
-              <a:rPr/>
-              <a:t>Pièces optimise les dépenses automobiles de tout le monde en Côte d'Ivoire — du propriétaire d'un véhicule au gestionnaire d'une flotte. Marketplace + flotte + réseau terrain, sur un marché de ~250 Mds FCFA/an, fragmenté et largement informel.</a:t>
-            </a:r>
-          </a:p>
-          <a:p>
-            <a:pPr lvl="0" indent="0" marL="1270000">
+              <a:rPr dirty="0" err="1"/>
+              <a:t>Pièces</a:t>
+            </a:r>
+            <a:r>
+              <a:rPr dirty="0"/>
+              <a:t> </a:t>
+            </a:r>
+            <a:r>
+              <a:rPr dirty="0" err="1"/>
+              <a:t>optimise</a:t>
+            </a:r>
+            <a:r>
+              <a:rPr dirty="0"/>
+              <a:t> les </a:t>
+            </a:r>
+            <a:r>
+              <a:rPr dirty="0" err="1"/>
+              <a:t>dépenses</a:t>
+            </a:r>
+            <a:r>
+              <a:rPr dirty="0"/>
+              <a:t> automobiles de tout le monde </a:t>
+            </a:r>
+            <a:r>
+              <a:rPr dirty="0" err="1"/>
+              <a:t>en</a:t>
+            </a:r>
+            <a:r>
+              <a:rPr dirty="0"/>
+              <a:t> Côte d'Ivoire </a:t>
+            </a:r>
+            <a:r>
+              <a:rPr lang="fr-FR" dirty="0"/>
+              <a:t>:</a:t>
+            </a:r>
+            <a:r>
+              <a:rPr dirty="0"/>
+              <a:t> du propriétaire d'un </a:t>
+            </a:r>
+            <a:r>
+              <a:rPr dirty="0" err="1"/>
+              <a:t>véhicule</a:t>
+            </a:r>
+            <a:r>
+              <a:rPr dirty="0"/>
+              <a:t> au </a:t>
+            </a:r>
+            <a:r>
+              <a:rPr dirty="0" err="1"/>
+              <a:t>gestionnaire</a:t>
+            </a:r>
+            <a:r>
+              <a:rPr dirty="0"/>
+              <a:t> </a:t>
+            </a:r>
+            <a:r>
+              <a:rPr dirty="0" err="1"/>
+              <a:t>d'une</a:t>
+            </a:r>
+            <a:r>
+              <a:rPr dirty="0"/>
+              <a:t> </a:t>
+            </a:r>
+            <a:r>
+              <a:rPr dirty="0" err="1"/>
+              <a:t>flotte</a:t>
+            </a:r>
+            <a:r>
+              <a:rPr dirty="0"/>
+              <a:t>. </a:t>
+            </a:r>
+            <a:endParaRPr lang="fr-FR" dirty="0"/>
+          </a:p>
+          <a:p>
+            <a:pPr marL="0" lvl="0" indent="0">
               <a:buNone/>
             </a:pPr>
             <a:r>
-              <a:rPr sz="2000"/>
-              <a:t>La pièce qu'il te faut, </a:t>
-            </a:r>
-            <a:r>
-              <a:rPr sz="2000" b="1"/>
-              <a:t>au juste prix</a:t>
-            </a:r>
-            <a:r>
-              <a:rPr sz="2000"/>
-              <a:t>, livrée et garantie. Pre-seed ~1 M EUR · Juin 2026 · Abidjan</a:t>
+              <a:rPr dirty="0"/>
+              <a:t>Marketplace + </a:t>
+            </a:r>
+            <a:r>
+              <a:rPr dirty="0" err="1"/>
+              <a:t>flotte</a:t>
+            </a:r>
+            <a:r>
+              <a:rPr dirty="0"/>
+              <a:t> + </a:t>
+            </a:r>
+            <a:r>
+              <a:rPr dirty="0" err="1"/>
+              <a:t>réseau</a:t>
+            </a:r>
+            <a:r>
+              <a:rPr dirty="0"/>
+              <a:t> terrain, sur un </a:t>
+            </a:r>
+            <a:r>
+              <a:rPr dirty="0" err="1"/>
+              <a:t>marché</a:t>
+            </a:r>
+            <a:r>
+              <a:rPr dirty="0"/>
+              <a:t> de ~250 </a:t>
+            </a:r>
+            <a:r>
+              <a:rPr dirty="0" err="1"/>
+              <a:t>Mds</a:t>
+            </a:r>
+            <a:r>
+              <a:rPr dirty="0"/>
+              <a:t> FCFA/an, </a:t>
+            </a:r>
+            <a:r>
+              <a:rPr dirty="0" err="1"/>
+              <a:t>fragmenté</a:t>
+            </a:r>
+            <a:r>
+              <a:rPr dirty="0"/>
+              <a:t> et </a:t>
+            </a:r>
+            <a:r>
+              <a:rPr dirty="0" err="1"/>
+              <a:t>largement</a:t>
+            </a:r>
+            <a:r>
+              <a:rPr dirty="0"/>
+              <a:t> </a:t>
+            </a:r>
+            <a:r>
+              <a:rPr dirty="0" err="1"/>
+              <a:t>informel</a:t>
+            </a:r>
+            <a:r>
+              <a:rPr dirty="0"/>
+              <a:t>.</a:t>
+            </a:r>
+          </a:p>
+          <a:p>
+            <a:pPr marL="1270000" lvl="0" indent="0">
+              <a:buNone/>
+            </a:pPr>
+            <a:r>
+              <a:rPr sz="2000" dirty="0"/>
+              <a:t>La pièce </a:t>
+            </a:r>
+            <a:r>
+              <a:rPr sz="2000" dirty="0" err="1"/>
+              <a:t>qu'il</a:t>
+            </a:r>
+            <a:r>
+              <a:rPr sz="2000" dirty="0"/>
+              <a:t> </a:t>
+            </a:r>
+            <a:r>
+              <a:rPr sz="2000" dirty="0" err="1"/>
+              <a:t>te</a:t>
+            </a:r>
+            <a:r>
+              <a:rPr sz="2000" dirty="0"/>
+              <a:t> faut, </a:t>
+            </a:r>
+            <a:r>
+              <a:rPr sz="2000" b="1" dirty="0"/>
+              <a:t>au </a:t>
+            </a:r>
+            <a:r>
+              <a:rPr sz="2000" b="1" dirty="0" err="1"/>
+              <a:t>juste</a:t>
+            </a:r>
+            <a:r>
+              <a:rPr sz="2000" b="1" dirty="0"/>
+              <a:t> prix</a:t>
+            </a:r>
+            <a:r>
+              <a:rPr sz="2000" dirty="0"/>
+              <a:t>, </a:t>
+            </a:r>
+            <a:r>
+              <a:rPr sz="2000" dirty="0" err="1"/>
+              <a:t>livrée</a:t>
+            </a:r>
+            <a:r>
+              <a:rPr sz="2000" dirty="0"/>
+              <a:t> et </a:t>
+            </a:r>
+            <a:r>
+              <a:rPr sz="2000" dirty="0" err="1"/>
+              <a:t>garantie</a:t>
+            </a:r>
+            <a:r>
+              <a:rPr sz="2000" dirty="0"/>
+              <a:t>. Pre-seed ~1 M EUR · </a:t>
+            </a:r>
+            <a:r>
+              <a:rPr sz="2000" dirty="0" err="1"/>
+              <a:t>Juin</a:t>
+            </a:r>
+            <a:r>
+              <a:rPr sz="2000" dirty="0"/>
+              <a:t> 2026 · Abidjan</a:t>
             </a:r>
           </a:p>
         </p:txBody>
       </p:sp>
     </p:spTree>
   </p:cSld>
+  <p:clrMapOvr>
+    <a:masterClrMapping/>
+  </p:clrMapOvr>
 </p:sld>
 </file>
 
@@ -4393,11 +4675,10 @@
           <a:bodyPr/>
           <a:lstStyle/>
           <a:p>
-            <a:pPr lvl="0" indent="0" marL="0">
+            <a:pPr marL="0" lvl="0" indent="0">
               <a:buNone/>
             </a:pPr>
             <a:r>
-              <a:rPr/>
               <a:t>Le problème</a:t>
             </a:r>
           </a:p>
@@ -4415,14 +4696,15 @@
         </p:nvSpPr>
         <p:spPr/>
         <p:txBody>
-          <a:bodyPr/>
-          <a:lstStyle/>
-          <a:p>
-            <a:pPr lvl="0" indent="0" marL="0">
+          <a:bodyPr>
+            <a:normAutofit fontScale="92500" lnSpcReduction="20000"/>
+          </a:bodyPr>
+          <a:lstStyle/>
+          <a:p>
+            <a:pPr marL="0" lvl="0" indent="0">
               <a:buNone/>
             </a:pPr>
             <a:r>
-              <a:rPr/>
               <a:t>Acheter une pièce auto à Abidjan = un parcours du combattant. Le marché est </a:t>
             </a:r>
             <a:r>
@@ -4430,12 +4712,11 @@
               <a:t>largement informel</a:t>
             </a:r>
             <a:r>
-              <a:rPr/>
               <a:t> : pas de catalogue, pas de prix affiché, pas de garantie, pas de facture.</a:t>
             </a:r>
           </a:p>
           <a:p>
-            <a:pPr lvl="0" indent="0" marL="0">
+            <a:pPr marL="0" lvl="0" indent="0">
               <a:buNone/>
             </a:pPr>
             <a:r>
@@ -4443,7 +4724,6 @@
               <a:t>Chaque intermédiaire ajoute sa marge</a:t>
             </a:r>
             <a:r>
-              <a:rPr/>
               <a:t> — importateur, grossiste, détaillant, mécanicien : l'acheteur paie l'accumulation, sans jamais voir le vrai prix.</a:t>
             </a:r>
           </a:p>
@@ -4454,7 +4734,6 @@
               <a:t>Propriétaire</a:t>
             </a:r>
             <a:r>
-              <a:rPr/>
               <a:t> : paie 30 à 60 % trop cher, sans garantie.</a:t>
             </a:r>
           </a:p>
@@ -4465,7 +4744,6 @@
               <a:t>Flotte</a:t>
             </a:r>
             <a:r>
-              <a:rPr/>
               <a:t> : perd </a:t>
             </a:r>
             <a:r>
@@ -4473,7 +4751,6 @@
               <a:t>25 000 à 50 000 F/jour</a:t>
             </a:r>
             <a:r>
-              <a:rPr/>
               <a:t> par véhicule immobilisé ; budget pièces opaque.</a:t>
             </a:r>
           </a:p>
@@ -4484,7 +4761,6 @@
               <a:t>Vendeur</a:t>
             </a:r>
             <a:r>
-              <a:rPr/>
               <a:t> : enfermé dans son comptoir, invisible en ligne.</a:t>
             </a:r>
           </a:p>
@@ -4495,7 +4771,6 @@
               <a:t>État</a:t>
             </a:r>
             <a:r>
-              <a:rPr/>
               <a:t> : ni TVA, ni traçabilité.</a:t>
             </a:r>
           </a:p>
@@ -4503,6 +4778,9 @@
       </p:sp>
     </p:spTree>
   </p:cSld>
+  <p:clrMapOvr>
+    <a:masterClrMapping/>
+  </p:clrMapOvr>
 </p:sld>
 </file>
 
@@ -4538,11 +4816,10 @@
           <a:bodyPr/>
           <a:lstStyle/>
           <a:p>
-            <a:pPr lvl="0" indent="0" marL="0">
+            <a:pPr marL="0" lvl="0" indent="0">
               <a:buNone/>
             </a:pPr>
             <a:r>
-              <a:rPr/>
               <a:t>La solution</a:t>
             </a:r>
           </a:p>
@@ -4560,14 +4837,15 @@
         </p:nvSpPr>
         <p:spPr/>
         <p:txBody>
-          <a:bodyPr/>
-          <a:lstStyle/>
-          <a:p>
-            <a:pPr lvl="0" indent="0" marL="0">
+          <a:bodyPr>
+            <a:normAutofit fontScale="92500" lnSpcReduction="10000"/>
+          </a:bodyPr>
+          <a:lstStyle/>
+          <a:p>
+            <a:pPr marL="0" lvl="0" indent="0">
               <a:buNone/>
             </a:pPr>
             <a:r>
-              <a:rPr/>
               <a:t>Trois produits, une seule infrastructure :</a:t>
             </a:r>
           </a:p>
@@ -4578,7 +4856,6 @@
               <a:t>Marketplace tripartite</a:t>
             </a:r>
             <a:r>
-              <a:rPr/>
               <a:t> — le mécanicien identifie, le vendeur livre, le propriétaire </a:t>
             </a:r>
             <a:r>
@@ -4586,7 +4863,6 @@
               <a:t>paie à la livraison</a:t>
             </a:r>
             <a:r>
-              <a:rPr/>
               <a:t>. Prix et condition affichés, garantie, facture.</a:t>
             </a:r>
           </a:p>
@@ -4597,7 +4873,6 @@
               <a:t>Suite Flotte (B2B)</a:t>
             </a:r>
             <a:r>
-              <a:rPr/>
               <a:t> — pilotage du coût total de possession, détection des véhicules « gouffres », livraison express, conformité fiscale.</a:t>
             </a:r>
           </a:p>
@@ -4608,7 +4883,6 @@
               <a:t>Réseau Liaison</a:t>
             </a:r>
             <a:r>
-              <a:rPr/>
               <a:t> — des agents terrain digitalisent les vendeurs </a:t>
             </a:r>
             <a:r>
@@ -4616,12 +4890,11 @@
               <a:t>formels et informels</a:t>
             </a:r>
             <a:r>
-              <a:rPr/>
               <a:t>, de l'importateur en gros au détaillant — même hors ligne.</a:t>
             </a:r>
           </a:p>
           <a:p>
-            <a:pPr lvl="0" indent="0" marL="1270000">
+            <a:pPr marL="1270000" lvl="0" indent="0">
               <a:buNone/>
             </a:pPr>
             <a:r>
@@ -4641,6 +4914,9 @@
       </p:sp>
     </p:spTree>
   </p:cSld>
+  <p:clrMapOvr>
+    <a:masterClrMapping/>
+  </p:clrMapOvr>
 </p:sld>
 </file>
 
@@ -4676,11 +4952,10 @@
           <a:bodyPr/>
           <a:lstStyle/>
           <a:p>
-            <a:pPr lvl="0" indent="0" marL="0">
+            <a:pPr marL="0" lvl="0" indent="0">
               <a:buNone/>
             </a:pPr>
             <a:r>
-              <a:rPr/>
               <a:t>Le produit est déjà construit</a:t>
             </a:r>
           </a:p>
@@ -4698,12 +4973,13 @@
         </p:nvSpPr>
         <p:spPr/>
         <p:txBody>
-          <a:bodyPr/>
+          <a:bodyPr>
+            <a:normAutofit fontScale="92500"/>
+          </a:bodyPr>
           <a:lstStyle/>
           <a:p>
             <a:pPr lvl="0"/>
             <a:r>
-              <a:rPr/>
               <a:t>Marketplace, </a:t>
             </a:r>
             <a:r>
@@ -4711,14 +4987,12 @@
               <a:t>paiement à la livraison</a:t>
             </a:r>
             <a:r>
-              <a:rPr/>
               <a:t>, garantie, facture — en production.</a:t>
             </a:r>
           </a:p>
           <a:p>
             <a:pPr lvl="0"/>
             <a:r>
-              <a:rPr/>
               <a:t>Recherche pièce par </a:t>
             </a:r>
             <a:r>
@@ -4726,7 +5000,6 @@
               <a:t>texte / photo IA / VIN</a:t>
             </a:r>
             <a:r>
-              <a:rPr/>
               <a:t>, fitment véhicule CI.</a:t>
             </a:r>
           </a:p>
@@ -4737,7 +5010,6 @@
               <a:t>Suite Flotte</a:t>
             </a:r>
             <a:r>
-              <a:rPr/>
               <a:t> (Pro 5 000 F · Pro + 10 000 F par véhicule/mois) + calculateur ROI.</a:t>
             </a:r>
           </a:p>
@@ -4748,7 +5020,6 @@
               <a:t>Bot WhatsApp</a:t>
             </a:r>
             <a:r>
-              <a:rPr/>
               <a:t>, portail entreprise en ligne sur </a:t>
             </a:r>
             <a:r>
@@ -4758,7 +5029,6 @@
               <a:t>flotte.pieces.ci</a:t>
             </a:r>
             <a:r>
-              <a:rPr/>
               <a:t>.</a:t>
             </a:r>
           </a:p>
@@ -4769,7 +5039,6 @@
               <a:t>7 137 annonces</a:t>
             </a:r>
             <a:r>
-              <a:rPr/>
               <a:t> déjà ingérées au catalogue (Jumia, CoinAfrique, global-auto).</a:t>
             </a:r>
           </a:p>
@@ -4777,6 +5046,9 @@
       </p:sp>
     </p:spTree>
   </p:cSld>
+  <p:clrMapOvr>
+    <a:masterClrMapping/>
+  </p:clrMapOvr>
 </p:sld>
 </file>
 
@@ -4817,11 +5089,10 @@
           <a:bodyPr/>
           <a:lstStyle/>
           <a:p>
-            <a:pPr lvl="0" indent="0" marL="0">
+            <a:pPr marL="0" lvl="0" indent="0">
               <a:buNone/>
             </a:pPr>
             <a:r>
-              <a:rPr/>
               <a:t>Le marché</a:t>
             </a:r>
           </a:p>
@@ -4834,7 +5105,7 @@
             <a:spLocks noGrp="1"/>
           </p:cNvSpPr>
           <p:nvPr>
-            <p:ph idx="2" sz="half" type="body"/>
+            <p:ph type="body" sz="half" idx="2"/>
           </p:nvPr>
         </p:nvSpPr>
         <p:spPr/>
@@ -4842,11 +5113,10 @@
           <a:bodyPr/>
           <a:lstStyle/>
           <a:p>
-            <a:pPr lvl="0" indent="0" marL="0">
+            <a:pPr marL="0" lvl="0" indent="0">
               <a:buNone/>
             </a:pPr>
             <a:r>
-              <a:rPr/>
               <a:t>Parc national </a:t>
             </a:r>
             <a:r>
@@ -4854,7 +5124,6 @@
               <a:t>~1,2 M véhicules</a:t>
             </a:r>
             <a:r>
-              <a:rPr/>
               <a:t> (Min. Transports, 2022). Secteur auto </a:t>
             </a:r>
             <a:r>
@@ -4862,7 +5131,6 @@
               <a:t>~400–420 Mds F/an</a:t>
             </a:r>
             <a:r>
-              <a:rPr/>
               <a:t>. À une take rate de ~10 %, le SOM représente </a:t>
             </a:r>
             <a:r>
@@ -4870,7 +5138,6 @@
               <a:t>4–6 Mds FCFA de revenu net annuel</a:t>
             </a:r>
             <a:r>
-              <a:rPr/>
               <a:t>.</a:t>
             </a:r>
           </a:p>
@@ -4888,7 +5155,7 @@
         </p:nvGraphicFramePr>
         <p:xfrm>
           <a:off x="3568700" y="203200"/>
-          <a:ext cx="5105400" cy="4381500"/>
+          <a:ext cx="5105400" cy="1188720"/>
         </p:xfrm>
         <a:graphic>
           <a:graphicData uri="http://schemas.openxmlformats.org/drawingml/2006/table">
@@ -4897,8 +5164,20 @@
                 <a:tableStyleId>{5C22544A-7EE6-4342-B048-85BDC9FD1C3A}</a:tableStyleId>
               </a:tblPr>
               <a:tblGrid>
-                <a:gridCol w="2552700"/>
-                <a:gridCol w="2552700"/>
+                <a:gridCol w="2552700">
+                  <a:extLst>
+                    <a:ext uri="{9D8B030D-6E8A-4147-A177-3AD203B41FA5}">
+                      <a16:colId xmlns:a16="http://schemas.microsoft.com/office/drawing/2014/main" val="20000"/>
+                    </a:ext>
+                  </a:extLst>
+                </a:gridCol>
+                <a:gridCol w="2552700">
+                  <a:extLst>
+                    <a:ext uri="{9D8B030D-6E8A-4147-A177-3AD203B41FA5}">
+                      <a16:colId xmlns:a16="http://schemas.microsoft.com/office/drawing/2014/main" val="20001"/>
+                    </a:ext>
+                  </a:extLst>
+                </a:gridCol>
               </a:tblGrid>
               <a:tr h="0">
                 <a:tc>
@@ -4916,17 +5195,21 @@
                     <a:bodyPr/>
                     <a:lstStyle/>
                     <a:p>
-                      <a:pPr lvl="0" indent="0" marL="0">
+                      <a:pPr marL="0" lvl="0" indent="0">
                         <a:buNone/>
                       </a:pPr>
                       <a:r>
-                        <a:rPr/>
                         <a:t>Marché pièces / an</a:t>
                       </a:r>
                     </a:p>
                   </a:txBody>
                   <a:tcPr/>
                 </a:tc>
+                <a:extLst>
+                  <a:ext uri="{0D108BD9-81ED-4DB2-BD59-A6C34878D82A}">
+                    <a16:rowId xmlns:a16="http://schemas.microsoft.com/office/drawing/2014/main" val="10000"/>
+                  </a:ext>
+                </a:extLst>
               </a:tr>
               <a:tr h="0">
                 <a:tc>
@@ -4934,7 +5217,7 @@
                     <a:bodyPr/>
                     <a:lstStyle/>
                     <a:p>
-                      <a:pPr lvl="0" indent="0" marL="0">
+                      <a:pPr marL="0" lvl="0" indent="0">
                         <a:buNone/>
                       </a:pPr>
                       <a:r>
@@ -4942,18 +5225,18 @@
                         <a:t>TAM</a:t>
                       </a:r>
                       <a:r>
-                        <a:rPr/>
                         <a:t> — national (pièces seules)</a:t>
                       </a:r>
                     </a:p>
                   </a:txBody>
+                  <a:tcPr/>
                 </a:tc>
                 <a:tc>
                   <a:txBody>
                     <a:bodyPr/>
                     <a:lstStyle/>
                     <a:p>
-                      <a:pPr lvl="0" indent="0" marL="0">
+                      <a:pPr marL="0" lvl="0" indent="0">
                         <a:buNone/>
                       </a:pPr>
                       <a:r>
@@ -4962,7 +5245,13 @@
                       </a:r>
                     </a:p>
                   </a:txBody>
+                  <a:tcPr/>
                 </a:tc>
+                <a:extLst>
+                  <a:ext uri="{0D108BD9-81ED-4DB2-BD59-A6C34878D82A}">
+                    <a16:rowId xmlns:a16="http://schemas.microsoft.com/office/drawing/2014/main" val="10001"/>
+                  </a:ext>
+                </a:extLst>
               </a:tr>
               <a:tr h="0">
                 <a:tc>
@@ -4970,7 +5259,7 @@
                     <a:bodyPr/>
                     <a:lstStyle/>
                     <a:p>
-                      <a:pPr lvl="0" indent="0" marL="0">
+                      <a:pPr marL="0" lvl="0" indent="0">
                         <a:buNone/>
                       </a:pPr>
                       <a:r>
@@ -4978,18 +5267,18 @@
                         <a:t>SAM</a:t>
                       </a:r>
                       <a:r>
-                        <a:rPr/>
                         <a:t> — Abidjan adressable</a:t>
                       </a:r>
                     </a:p>
                   </a:txBody>
+                  <a:tcPr/>
                 </a:tc>
                 <a:tc>
                   <a:txBody>
                     <a:bodyPr/>
                     <a:lstStyle/>
                     <a:p>
-                      <a:pPr lvl="0" indent="0" marL="0">
+                      <a:pPr marL="0" lvl="0" indent="0">
                         <a:buNone/>
                       </a:pPr>
                       <a:r>
@@ -4998,7 +5287,13 @@
                       </a:r>
                     </a:p>
                   </a:txBody>
+                  <a:tcPr/>
                 </a:tc>
+                <a:extLst>
+                  <a:ext uri="{0D108BD9-81ED-4DB2-BD59-A6C34878D82A}">
+                    <a16:rowId xmlns:a16="http://schemas.microsoft.com/office/drawing/2014/main" val="10002"/>
+                  </a:ext>
+                </a:extLst>
               </a:tr>
               <a:tr h="0">
                 <a:tc>
@@ -5006,7 +5301,7 @@
                     <a:bodyPr/>
                     <a:lstStyle/>
                     <a:p>
-                      <a:pPr lvl="0" indent="0" marL="0">
+                      <a:pPr marL="0" lvl="0" indent="0">
                         <a:buNone/>
                       </a:pPr>
                       <a:r>
@@ -5014,18 +5309,18 @@
                         <a:t>SOM</a:t>
                       </a:r>
                       <a:r>
-                        <a:rPr/>
                         <a:t> — 5 ans, GMV intermédié</a:t>
                       </a:r>
                     </a:p>
                   </a:txBody>
+                  <a:tcPr/>
                 </a:tc>
                 <a:tc>
                   <a:txBody>
                     <a:bodyPr/>
                     <a:lstStyle/>
                     <a:p>
-                      <a:pPr lvl="0" indent="0" marL="0">
+                      <a:pPr marL="0" lvl="0" indent="0">
                         <a:buNone/>
                       </a:pPr>
                       <a:r>
@@ -5034,7 +5329,13 @@
                       </a:r>
                     </a:p>
                   </a:txBody>
+                  <a:tcPr/>
                 </a:tc>
+                <a:extLst>
+                  <a:ext uri="{0D108BD9-81ED-4DB2-BD59-A6C34878D82A}">
+                    <a16:rowId xmlns:a16="http://schemas.microsoft.com/office/drawing/2014/main" val="10003"/>
+                  </a:ext>
+                </a:extLst>
               </a:tr>
             </a:tbl>
           </a:graphicData>
@@ -5042,6 +5343,9 @@
       </p:graphicFrame>
     </p:spTree>
   </p:cSld>
+  <p:clrMapOvr>
+    <a:masterClrMapping/>
+  </p:clrMapOvr>
 </p:sld>
 </file>
 
@@ -5077,11 +5381,10 @@
           <a:bodyPr/>
           <a:lstStyle/>
           <a:p>
-            <a:pPr lvl="0" indent="0" marL="0">
+            <a:pPr marL="0" lvl="0" indent="0">
               <a:buNone/>
             </a:pPr>
             <a:r>
-              <a:rPr/>
               <a:t>Pourquoi maintenant</a:t>
             </a:r>
           </a:p>
@@ -5099,7 +5402,9 @@
         </p:nvSpPr>
         <p:spPr/>
         <p:txBody>
-          <a:bodyPr/>
+          <a:bodyPr>
+            <a:normAutofit fontScale="92500" lnSpcReduction="20000"/>
+          </a:bodyPr>
           <a:lstStyle/>
           <a:p>
             <a:pPr lvl="0"/>
@@ -5108,7 +5413,6 @@
               <a:t>Uber a quitté la Côte d'Ivoire (sept. 2025)</a:t>
             </a:r>
             <a:r>
-              <a:rPr/>
               <a:t> → </a:t>
             </a:r>
             <a:r>
@@ -5116,7 +5420,6 @@
               <a:t>Yango ultra-dominant</a:t>
             </a:r>
             <a:r>
-              <a:rPr/>
               <a:t> : ~25 000 véhicules, **~100 000 courses/jour**, 160+ entreprises de flotte, HQ régional à Abidjan. Un partenaire flotte évident.</a:t>
             </a:r>
           </a:p>
@@ -5127,7 +5430,6 @@
               <a:t>Parc qui rajeunit</a:t>
             </a:r>
             <a:r>
-              <a:rPr/>
               <a:t> : importations de neuf triplées depuis 2017, restriction de l'âge des véhicules.</a:t>
             </a:r>
           </a:p>
@@ -5138,7 +5440,6 @@
               <a:t>Mobile Money massif</a:t>
             </a:r>
             <a:r>
-              <a:rPr/>
               <a:t> (Orange Money, MTN, Wave) → paiement à la livraison fiable et traçable.</a:t>
             </a:r>
           </a:p>
@@ -5149,12 +5450,11 @@
               <a:t>Formalisation fiscale (FNE-CI)</a:t>
             </a:r>
             <a:r>
-              <a:rPr/>
               <a:t> → fenêtre pour devenir le standard de la facture pièce.</a:t>
             </a:r>
           </a:p>
           <a:p>
-            <a:pPr lvl="0" indent="0" marL="1270000">
+            <a:pPr marL="1270000" lvl="0" indent="0">
               <a:buNone/>
             </a:pPr>
             <a:r>
@@ -5174,6 +5474,9 @@
       </p:sp>
     </p:spTree>
   </p:cSld>
+  <p:clrMapOvr>
+    <a:masterClrMapping/>
+  </p:clrMapOvr>
 </p:sld>
 </file>
 
@@ -5209,11 +5512,10 @@
           <a:bodyPr/>
           <a:lstStyle/>
           <a:p>
-            <a:pPr lvl="0" indent="0" marL="0">
+            <a:pPr marL="0" lvl="0" indent="0">
               <a:buNone/>
             </a:pPr>
             <a:r>
-              <a:rPr/>
               <a:t>Le beachhead : le VTC</a:t>
             </a:r>
           </a:p>
@@ -5231,14 +5533,15 @@
         </p:nvSpPr>
         <p:spPr/>
         <p:txBody>
-          <a:bodyPr/>
-          <a:lstStyle/>
-          <a:p>
-            <a:pPr lvl="0" indent="0" marL="0">
+          <a:bodyPr>
+            <a:normAutofit fontScale="92500" lnSpcReduction="20000"/>
+          </a:bodyPr>
+          <a:lstStyle/>
+          <a:p>
+            <a:pPr marL="0" lvl="0" indent="0">
               <a:buNone/>
             </a:pPr>
             <a:r>
-              <a:rPr/>
               <a:t>Le VTC ivoirien a explosé : </a:t>
             </a:r>
             <a:r>
@@ -5246,7 +5549,6 @@
               <a:t>~30 000 véhicules en 2026</a:t>
             </a:r>
             <a:r>
-              <a:rPr/>
               <a:t> (vs 5–6k en 2024), Yango ~25 000 à Abidjan. C'est </a:t>
             </a:r>
             <a:r>
@@ -5254,14 +5556,12 @@
               <a:t>le meilleur point d'entrée</a:t>
             </a:r>
             <a:r>
-              <a:rPr/>
               <a:t>, pas le plus gros segment :</a:t>
             </a:r>
           </a:p>
           <a:p>
             <a:pPr lvl="0"/>
             <a:r>
-              <a:rPr/>
               <a:t>Un VTC roule </a:t>
             </a:r>
             <a:r>
@@ -5269,7 +5569,6 @@
               <a:t>~44 000 km/an</a:t>
             </a:r>
             <a:r>
-              <a:rPr/>
               <a:t> (3× un particulier) → use ses pièces 3× plus vite (</a:t>
             </a:r>
             <a:r>
@@ -5277,14 +5576,12 @@
               <a:t>~1,3 M F/an</a:t>
             </a:r>
             <a:r>
-              <a:rPr/>
               <a:t> de pièces).</a:t>
             </a:r>
           </a:p>
           <a:p>
             <a:pPr lvl="0"/>
             <a:r>
-              <a:rPr/>
               <a:t>Chaque jour d'immobilisation </a:t>
             </a:r>
             <a:r>
@@ -5292,7 +5589,6 @@
               <a:t>détruit du revenu</a:t>
             </a:r>
             <a:r>
-              <a:rPr/>
               <a:t> (15–30k F/jour) → douleur aiguë et mesurable.</a:t>
             </a:r>
           </a:p>
@@ -5303,14 +5599,12 @@
               <a:t>~160 entreprises de flotte</a:t>
             </a:r>
             <a:r>
-              <a:rPr/>
               <a:t> Yango = cibles B2B concentrées et immédiates.</a:t>
             </a:r>
           </a:p>
           <a:p>
             <a:pPr lvl="0"/>
             <a:r>
-              <a:rPr/>
               <a:t>Idéal pour prouver le ROI et bâtir la </a:t>
             </a:r>
             <a:r>
@@ -5318,7 +5612,6 @@
               <a:t>data fitments</a:t>
             </a:r>
             <a:r>
-              <a:rPr/>
               <a:t>, avant d'étendre au parc entier (taxis, gbaka, BTP, corporate).</a:t>
             </a:r>
           </a:p>
@@ -5326,6 +5619,9 @@
       </p:sp>
     </p:spTree>
   </p:cSld>
+  <p:clrMapOvr>
+    <a:masterClrMapping/>
+  </p:clrMapOvr>
 </p:sld>
 </file>
 
@@ -5366,11 +5662,10 @@
           <a:bodyPr/>
           <a:lstStyle/>
           <a:p>
-            <a:pPr lvl="0" indent="0" marL="0">
+            <a:pPr marL="0" lvl="0" indent="0">
               <a:buNone/>
             </a:pPr>
             <a:r>
-              <a:rPr/>
               <a:t>Modèle économique</a:t>
             </a:r>
           </a:p>
@@ -5383,7 +5678,7 @@
             <a:spLocks noGrp="1"/>
           </p:cNvSpPr>
           <p:nvPr>
-            <p:ph idx="2" sz="half" type="body"/>
+            <p:ph type="body" sz="half" idx="2"/>
           </p:nvPr>
         </p:nvSpPr>
         <p:spPr/>
@@ -5391,7 +5686,7 @@
           <a:bodyPr/>
           <a:lstStyle/>
           <a:p>
-            <a:pPr lvl="0" indent="0" marL="0">
+            <a:pPr marL="0" lvl="0" indent="0">
               <a:buNone/>
             </a:pPr>
             <a:r>
@@ -5399,7 +5694,6 @@
               <a:t>Unit economics</a:t>
             </a:r>
             <a:r>
-              <a:rPr/>
               <a:t> : panier moyen </a:t>
             </a:r>
             <a:r>
@@ -5407,7 +5701,6 @@
               <a:t>32 000 F</a:t>
             </a:r>
             <a:r>
-              <a:rPr/>
               <a:t>, take rate </a:t>
             </a:r>
             <a:r>
@@ -5415,7 +5708,6 @@
               <a:t>10 %</a:t>
             </a:r>
             <a:r>
-              <a:rPr/>
               <a:t> → </a:t>
             </a:r>
             <a:r>
@@ -5423,7 +5715,6 @@
               <a:t>3 200 F/commande</a:t>
             </a:r>
             <a:r>
-              <a:rPr/>
               <a:t> · LTV Flotte Pro </a:t>
             </a:r>
             <a:r>
@@ -5431,7 +5722,6 @@
               <a:t>~85 000 F/véhicule</a:t>
             </a:r>
             <a:r>
-              <a:rPr/>
               <a:t> · </a:t>
             </a:r>
             <a:r>
@@ -5439,7 +5729,6 @@
               <a:t>LTV/CAC &gt; 4</a:t>
             </a:r>
             <a:r>
-              <a:rPr/>
               <a:t> dès M12.</a:t>
             </a:r>
           </a:p>
@@ -5457,7 +5746,7 @@
         </p:nvGraphicFramePr>
         <p:xfrm>
           <a:off x="3568700" y="203200"/>
-          <a:ext cx="5105400" cy="4381500"/>
+          <a:ext cx="5105400" cy="2308860"/>
         </p:xfrm>
         <a:graphic>
           <a:graphicData uri="http://schemas.openxmlformats.org/drawingml/2006/table">
@@ -5466,9 +5755,27 @@
                 <a:tableStyleId>{5C22544A-7EE6-4342-B048-85BDC9FD1C3A}</a:tableStyleId>
               </a:tblPr>
               <a:tblGrid>
-                <a:gridCol w="1701800"/>
-                <a:gridCol w="1701800"/>
-                <a:gridCol w="1701800"/>
+                <a:gridCol w="1701800">
+                  <a:extLst>
+                    <a:ext uri="{9D8B030D-6E8A-4147-A177-3AD203B41FA5}">
+                      <a16:colId xmlns:a16="http://schemas.microsoft.com/office/drawing/2014/main" val="20000"/>
+                    </a:ext>
+                  </a:extLst>
+                </a:gridCol>
+                <a:gridCol w="1701800">
+                  <a:extLst>
+                    <a:ext uri="{9D8B030D-6E8A-4147-A177-3AD203B41FA5}">
+                      <a16:colId xmlns:a16="http://schemas.microsoft.com/office/drawing/2014/main" val="20001"/>
+                    </a:ext>
+                  </a:extLst>
+                </a:gridCol>
+                <a:gridCol w="1701800">
+                  <a:extLst>
+                    <a:ext uri="{9D8B030D-6E8A-4147-A177-3AD203B41FA5}">
+                      <a16:colId xmlns:a16="http://schemas.microsoft.com/office/drawing/2014/main" val="20002"/>
+                    </a:ext>
+                  </a:extLst>
+                </a:gridCol>
               </a:tblGrid>
               <a:tr h="0">
                 <a:tc>
@@ -5476,11 +5783,10 @@
                     <a:bodyPr/>
                     <a:lstStyle/>
                     <a:p>
-                      <a:pPr lvl="0" indent="0" marL="0">
+                      <a:pPr marL="0" lvl="0" indent="0">
                         <a:buNone/>
                       </a:pPr>
                       <a:r>
-                        <a:rPr/>
                         <a:t>Flux</a:t>
                       </a:r>
                     </a:p>
@@ -5492,11 +5798,10 @@
                     <a:bodyPr/>
                     <a:lstStyle/>
                     <a:p>
-                      <a:pPr lvl="0" indent="0" marL="0">
+                      <a:pPr marL="0" lvl="0" indent="0">
                         <a:buNone/>
                       </a:pPr>
                       <a:r>
-                        <a:rPr/>
                         <a:t>Mécanique</a:t>
                       </a:r>
                     </a:p>
@@ -5508,17 +5813,21 @@
                     <a:bodyPr/>
                     <a:lstStyle/>
                     <a:p>
-                      <a:pPr lvl="0" indent="0" marL="0">
+                      <a:pPr marL="0" lvl="0" indent="0">
                         <a:buNone/>
                       </a:pPr>
                       <a:r>
-                        <a:rPr/>
                         <a:t>An 3</a:t>
                       </a:r>
                     </a:p>
                   </a:txBody>
                   <a:tcPr/>
                 </a:tc>
+                <a:extLst>
+                  <a:ext uri="{0D108BD9-81ED-4DB2-BD59-A6C34878D82A}">
+                    <a16:rowId xmlns:a16="http://schemas.microsoft.com/office/drawing/2014/main" val="10000"/>
+                  </a:ext>
+                </a:extLst>
               </a:tr>
               <a:tr h="0">
                 <a:tc>
@@ -5526,46 +5835,51 @@
                     <a:bodyPr/>
                     <a:lstStyle/>
                     <a:p>
-                      <a:pPr lvl="0" indent="0" marL="0">
+                      <a:pPr marL="0" lvl="0" indent="0">
                         <a:buNone/>
                       </a:pPr>
                       <a:r>
-                        <a:rPr/>
                         <a:t>Commission marketplace</a:t>
                       </a:r>
                     </a:p>
                   </a:txBody>
+                  <a:tcPr/>
                 </a:tc>
                 <a:tc>
                   <a:txBody>
                     <a:bodyPr/>
                     <a:lstStyle/>
                     <a:p>
-                      <a:pPr lvl="0" indent="0" marL="0">
+                      <a:pPr marL="0" lvl="0" indent="0">
                         <a:buNone/>
                       </a:pPr>
                       <a:r>
-                        <a:rPr/>
                         <a:t>7–15 %, au paiement</a:t>
                       </a:r>
                     </a:p>
                   </a:txBody>
+                  <a:tcPr/>
                 </a:tc>
                 <a:tc>
                   <a:txBody>
                     <a:bodyPr/>
                     <a:lstStyle/>
                     <a:p>
-                      <a:pPr lvl="0" indent="0" marL="0">
+                      <a:pPr marL="0" lvl="0" indent="0">
                         <a:buNone/>
                       </a:pPr>
                       <a:r>
-                        <a:rPr/>
                         <a:t>45 %</a:t>
                       </a:r>
                     </a:p>
                   </a:txBody>
+                  <a:tcPr/>
                 </a:tc>
+                <a:extLst>
+                  <a:ext uri="{0D108BD9-81ED-4DB2-BD59-A6C34878D82A}">
+                    <a16:rowId xmlns:a16="http://schemas.microsoft.com/office/drawing/2014/main" val="10001"/>
+                  </a:ext>
+                </a:extLst>
               </a:tr>
               <a:tr h="0">
                 <a:tc>
@@ -5573,46 +5887,51 @@
                     <a:bodyPr/>
                     <a:lstStyle/>
                     <a:p>
-                      <a:pPr lvl="0" indent="0" marL="0">
+                      <a:pPr marL="0" lvl="0" indent="0">
                         <a:buNone/>
                       </a:pPr>
                       <a:r>
-                        <a:rPr/>
                         <a:t>Abonnement Flotte Pro</a:t>
                       </a:r>
                     </a:p>
                   </a:txBody>
+                  <a:tcPr/>
                 </a:tc>
                 <a:tc>
                   <a:txBody>
                     <a:bodyPr/>
                     <a:lstStyle/>
                     <a:p>
-                      <a:pPr lvl="0" indent="0" marL="0">
+                      <a:pPr marL="0" lvl="0" indent="0">
                         <a:buNone/>
                       </a:pPr>
                       <a:r>
-                        <a:rPr/>
                         <a:t>5 000 F/véh/mois</a:t>
                       </a:r>
                     </a:p>
                   </a:txBody>
+                  <a:tcPr/>
                 </a:tc>
                 <a:tc>
                   <a:txBody>
                     <a:bodyPr/>
                     <a:lstStyle/>
                     <a:p>
-                      <a:pPr lvl="0" indent="0" marL="0">
+                      <a:pPr marL="0" lvl="0" indent="0">
                         <a:buNone/>
                       </a:pPr>
                       <a:r>
-                        <a:rPr/>
                         <a:t>35 %</a:t>
                       </a:r>
                     </a:p>
                   </a:txBody>
+                  <a:tcPr/>
                 </a:tc>
+                <a:extLst>
+                  <a:ext uri="{0D108BD9-81ED-4DB2-BD59-A6C34878D82A}">
+                    <a16:rowId xmlns:a16="http://schemas.microsoft.com/office/drawing/2014/main" val="10002"/>
+                  </a:ext>
+                </a:extLst>
               </a:tr>
               <a:tr h="0">
                 <a:tc>
@@ -5620,46 +5939,51 @@
                     <a:bodyPr/>
                     <a:lstStyle/>
                     <a:p>
-                      <a:pPr lvl="0" indent="0" marL="0">
+                      <a:pPr marL="0" lvl="0" indent="0">
                         <a:buNone/>
                       </a:pPr>
                       <a:r>
-                        <a:rPr/>
                         <a:t>Abonnement Flotte Pro +</a:t>
                       </a:r>
                     </a:p>
                   </a:txBody>
+                  <a:tcPr/>
                 </a:tc>
                 <a:tc>
                   <a:txBody>
                     <a:bodyPr/>
                     <a:lstStyle/>
                     <a:p>
-                      <a:pPr lvl="0" indent="0" marL="0">
+                      <a:pPr marL="0" lvl="0" indent="0">
                         <a:buNone/>
                       </a:pPr>
                       <a:r>
-                        <a:rPr/>
                         <a:t>10 000 F/véh/mois</a:t>
                       </a:r>
                     </a:p>
                   </a:txBody>
+                  <a:tcPr/>
                 </a:tc>
                 <a:tc>
                   <a:txBody>
                     <a:bodyPr/>
                     <a:lstStyle/>
                     <a:p>
-                      <a:pPr lvl="0" indent="0" marL="0">
+                      <a:pPr marL="0" lvl="0" indent="0">
                         <a:buNone/>
                       </a:pPr>
                       <a:r>
-                        <a:rPr/>
                         <a:t>15 %</a:t>
                       </a:r>
                     </a:p>
                   </a:txBody>
+                  <a:tcPr/>
                 </a:tc>
+                <a:extLst>
+                  <a:ext uri="{0D108BD9-81ED-4DB2-BD59-A6C34878D82A}">
+                    <a16:rowId xmlns:a16="http://schemas.microsoft.com/office/drawing/2014/main" val="10003"/>
+                  </a:ext>
+                </a:extLst>
               </a:tr>
               <a:tr h="0">
                 <a:tc>
@@ -5667,46 +5991,51 @@
                     <a:bodyPr/>
                     <a:lstStyle/>
                     <a:p>
-                      <a:pPr lvl="0" indent="0" marL="0">
+                      <a:pPr marL="0" lvl="0" indent="0">
                         <a:buNone/>
                       </a:pPr>
                       <a:r>
-                        <a:rPr/>
                         <a:t>Conformité / facturation</a:t>
                       </a:r>
                     </a:p>
                   </a:txBody>
+                  <a:tcPr/>
                 </a:tc>
                 <a:tc>
                   <a:txBody>
                     <a:bodyPr/>
                     <a:lstStyle/>
                     <a:p>
-                      <a:pPr lvl="0" indent="0" marL="0">
+                      <a:pPr marL="0" lvl="0" indent="0">
                         <a:buNone/>
                       </a:pPr>
                       <a:r>
-                        <a:rPr/>
                         <a:t>forfait FNE-CI</a:t>
                       </a:r>
                     </a:p>
                   </a:txBody>
+                  <a:tcPr/>
                 </a:tc>
                 <a:tc>
                   <a:txBody>
                     <a:bodyPr/>
                     <a:lstStyle/>
                     <a:p>
-                      <a:pPr lvl="0" indent="0" marL="0">
+                      <a:pPr marL="0" lvl="0" indent="0">
                         <a:buNone/>
                       </a:pPr>
                       <a:r>
-                        <a:rPr/>
                         <a:t>5 %</a:t>
                       </a:r>
                     </a:p>
                   </a:txBody>
+                  <a:tcPr/>
                 </a:tc>
+                <a:extLst>
+                  <a:ext uri="{0D108BD9-81ED-4DB2-BD59-A6C34878D82A}">
+                    <a16:rowId xmlns:a16="http://schemas.microsoft.com/office/drawing/2014/main" val="10004"/>
+                  </a:ext>
+                </a:extLst>
               </a:tr>
             </a:tbl>
           </a:graphicData>
@@ -5714,6 +6043,9 @@
       </p:graphicFrame>
     </p:spTree>
   </p:cSld>
+  <p:clrMapOvr>
+    <a:masterClrMapping/>
+  </p:clrMapOvr>
 </p:sld>
 </file>
 
@@ -6035,265 +6367,4 @@
   </a:objectDefaults>
   <a:extraClrSchemeLst/>
 </a:theme>
-</file>
-
-<file path=ppt/theme/theme2.xml><?xml version="1.0" encoding="utf-8"?>
-<a:theme xmlns:a="http://schemas.openxmlformats.org/drawingml/2006/main" name="Office Theme">
-  <a:themeElements>
-    <a:clrScheme name="Office">
-      <a:dk1>
-        <a:sysClr val="windowText" lastClr="000000"/>
-      </a:dk1>
-      <a:lt1>
-        <a:sysClr val="window" lastClr="FFFFFF"/>
-      </a:lt1>
-      <a:dk2>
-        <a:srgbClr val="44546A"/>
-      </a:dk2>
-      <a:lt2>
-        <a:srgbClr val="E7E6E6"/>
-      </a:lt2>
-      <a:accent1>
-        <a:srgbClr val="5B9BD5"/>
-      </a:accent1>
-      <a:accent2>
-        <a:srgbClr val="ED7D31"/>
-      </a:accent2>
-      <a:accent3>
-        <a:srgbClr val="A5A5A5"/>
-      </a:accent3>
-      <a:accent4>
-        <a:srgbClr val="FFC000"/>
-      </a:accent4>
-      <a:accent5>
-        <a:srgbClr val="4472C4"/>
-      </a:accent5>
-      <a:accent6>
-        <a:srgbClr val="70AD47"/>
-      </a:accent6>
-      <a:hlink>
-        <a:srgbClr val="0563C1"/>
-      </a:hlink>
-      <a:folHlink>
-        <a:srgbClr val="954F72"/>
-      </a:folHlink>
-    </a:clrScheme>
-    <a:fontScheme name="Office">
-      <a:majorFont>
-        <a:latin typeface="Calibri Light" panose="020F0302020204030204"/>
-        <a:ea typeface=""/>
-        <a:cs typeface=""/>
-        <a:font script="Jpan" typeface="ＭＳ Ｐゴシック"/>
-        <a:font script="Hang" typeface="맑은 고딕"/>
-        <a:font script="Hans" typeface="宋体"/>
-        <a:font script="Hant" typeface="新細明體"/>
-        <a:font script="Arab" typeface="Times New Roman"/>
-        <a:font script="Hebr" typeface="Times New Roman"/>
-        <a:font script="Thai" typeface="Angsana New"/>
-        <a:font script="Ethi" typeface="Nyala"/>
-        <a:font script="Beng" typeface="Vrinda"/>
-        <a:font script="Gujr" typeface="Shruti"/>
-        <a:font script="Khmr" typeface="MoolBoran"/>
-        <a:font script="Knda" typeface="Tunga"/>
-        <a:font script="Guru" typeface="Raavi"/>
-        <a:font script="Cans" typeface="Euphemia"/>
-        <a:font script="Cher" typeface="Plantagenet Cherokee"/>
-        <a:font script="Yiii" typeface="Microsoft Yi Baiti"/>
-        <a:font script="Tibt" typeface="Microsoft Himalaya"/>
-        <a:font script="Thaa" typeface="MV Boli"/>
-        <a:font script="Deva" typeface="Mangal"/>
-        <a:font script="Telu" typeface="Gautami"/>
-        <a:font script="Taml" typeface="Latha"/>
-        <a:font script="Syrc" typeface="Estrangelo Edessa"/>
-        <a:font script="Orya" typeface="Kalinga"/>
-        <a:font script="Mlym" typeface="Kartika"/>
-        <a:font script="Laoo" typeface="DokChampa"/>
-        <a:font script="Sinh" typeface="Iskoola Pota"/>
-        <a:font script="Mong" typeface="Mongolian Baiti"/>
-        <a:font script="Viet" typeface="Times New Roman"/>
-        <a:font script="Uigh" typeface="Microsoft Uighur"/>
-        <a:font script="Geor" typeface="Sylfaen"/>
-      </a:majorFont>
-      <a:minorFont>
-        <a:latin typeface="Calibri" panose="020F0502020204030204"/>
-        <a:ea typeface=""/>
-        <a:cs typeface=""/>
-        <a:font script="Jpan" typeface="ＭＳ Ｐゴシック"/>
-        <a:font script="Hang" typeface="맑은 고딕"/>
-        <a:font script="Hans" typeface="宋体"/>
-        <a:font script="Hant" typeface="新細明體"/>
-        <a:font script="Arab" typeface="Arial"/>
-        <a:font script="Hebr" typeface="Arial"/>
-        <a:font script="Thai" typeface="Cordia New"/>
-        <a:font script="Ethi" typeface="Nyala"/>
-        <a:font script="Beng" typeface="Vrinda"/>
-        <a:font script="Gujr" typeface="Shruti"/>
-        <a:font script="Khmr" typeface="DaunPenh"/>
-        <a:font script="Knda" typeface="Tunga"/>
-        <a:font script="Guru" typeface="Raavi"/>
-        <a:font script="Cans" typeface="Euphemia"/>
-        <a:font script="Cher" typeface="Plantagenet Cherokee"/>
-        <a:font script="Yiii" typeface="Microsoft Yi Baiti"/>
-        <a:font script="Tibt" typeface="Microsoft Himalaya"/>
-        <a:font script="Thaa" typeface="MV Boli"/>
-        <a:font script="Deva" typeface="Mangal"/>
-        <a:font script="Telu" typeface="Gautami"/>
-        <a:font script="Taml" typeface="Latha"/>
-        <a:font script="Syrc" typeface="Estrangelo Edessa"/>
-        <a:font script="Orya" typeface="Kalinga"/>
-        <a:font script="Mlym" typeface="Kartika"/>
-        <a:font script="Laoo" typeface="DokChampa"/>
-        <a:font script="Sinh" typeface="Iskoola Pota"/>
-        <a:font script="Mong" typeface="Mongolian Baiti"/>
-        <a:font script="Viet" typeface="Arial"/>
-        <a:font script="Uigh" typeface="Microsoft Uighur"/>
-        <a:font script="Geor" typeface="Sylfaen"/>
-      </a:minorFont>
-    </a:fontScheme>
-    <a:fmtScheme name="Office">
-      <a:fillStyleLst>
-        <a:solidFill>
-          <a:schemeClr val="phClr"/>
-        </a:solidFill>
-        <a:gradFill rotWithShape="1">
-          <a:gsLst>
-            <a:gs pos="0">
-              <a:schemeClr val="phClr">
-                <a:lumMod val="110000"/>
-                <a:satMod val="105000"/>
-                <a:tint val="67000"/>
-              </a:schemeClr>
-            </a:gs>
-            <a:gs pos="50000">
-              <a:schemeClr val="phClr">
-                <a:lumMod val="105000"/>
-                <a:satMod val="103000"/>
-                <a:tint val="73000"/>
-              </a:schemeClr>
-            </a:gs>
-            <a:gs pos="100000">
-              <a:schemeClr val="phClr">
-                <a:lumMod val="105000"/>
-                <a:satMod val="109000"/>
-                <a:tint val="81000"/>
-              </a:schemeClr>
-            </a:gs>
-          </a:gsLst>
-          <a:lin ang="5400000" scaled="0"/>
-        </a:gradFill>
-        <a:gradFill rotWithShape="1">
-          <a:gsLst>
-            <a:gs pos="0">
-              <a:schemeClr val="phClr">
-                <a:satMod val="103000"/>
-                <a:lumMod val="102000"/>
-                <a:tint val="94000"/>
-              </a:schemeClr>
-            </a:gs>
-            <a:gs pos="50000">
-              <a:schemeClr val="phClr">
-                <a:satMod val="110000"/>
-                <a:lumMod val="100000"/>
-                <a:shade val="100000"/>
-              </a:schemeClr>
-            </a:gs>
-            <a:gs pos="100000">
-              <a:schemeClr val="phClr">
-                <a:lumMod val="99000"/>
-                <a:satMod val="120000"/>
-                <a:shade val="78000"/>
-              </a:schemeClr>
-            </a:gs>
-          </a:gsLst>
-          <a:lin ang="5400000" scaled="0"/>
-        </a:gradFill>
-      </a:fillStyleLst>
-      <a:lnStyleLst>
-        <a:ln w="6350" cap="flat" cmpd="sng" algn="ctr">
-          <a:solidFill>
-            <a:schemeClr val="phClr"/>
-          </a:solidFill>
-          <a:prstDash val="solid"/>
-          <a:miter lim="800000"/>
-        </a:ln>
-        <a:ln w="12700" cap="flat" cmpd="sng" algn="ctr">
-          <a:solidFill>
-            <a:schemeClr val="phClr"/>
-          </a:solidFill>
-          <a:prstDash val="solid"/>
-          <a:miter lim="800000"/>
-        </a:ln>
-        <a:ln w="19050" cap="flat" cmpd="sng" algn="ctr">
-          <a:solidFill>
-            <a:schemeClr val="phClr"/>
-          </a:solidFill>
-          <a:prstDash val="solid"/>
-          <a:miter lim="800000"/>
-        </a:ln>
-      </a:lnStyleLst>
-      <a:effectStyleLst>
-        <a:effectStyle>
-          <a:effectLst/>
-        </a:effectStyle>
-        <a:effectStyle>
-          <a:effectLst/>
-        </a:effectStyle>
-        <a:effectStyle>
-          <a:effectLst>
-            <a:outerShdw blurRad="57150" dist="19050" dir="5400000" algn="ctr" rotWithShape="0">
-              <a:srgbClr val="000000">
-                <a:alpha val="63000"/>
-              </a:srgbClr>
-            </a:outerShdw>
-          </a:effectLst>
-        </a:effectStyle>
-      </a:effectStyleLst>
-      <a:bgFillStyleLst>
-        <a:solidFill>
-          <a:schemeClr val="phClr"/>
-        </a:solidFill>
-        <a:solidFill>
-          <a:schemeClr val="phClr">
-            <a:tint val="95000"/>
-            <a:satMod val="170000"/>
-          </a:schemeClr>
-        </a:solidFill>
-        <a:gradFill rotWithShape="1">
-          <a:gsLst>
-            <a:gs pos="0">
-              <a:schemeClr val="phClr">
-                <a:tint val="93000"/>
-                <a:satMod val="150000"/>
-                <a:shade val="98000"/>
-                <a:lumMod val="102000"/>
-              </a:schemeClr>
-            </a:gs>
-            <a:gs pos="50000">
-              <a:schemeClr val="phClr">
-                <a:tint val="98000"/>
-                <a:satMod val="130000"/>
-                <a:shade val="90000"/>
-                <a:lumMod val="103000"/>
-              </a:schemeClr>
-            </a:gs>
-            <a:gs pos="100000">
-              <a:schemeClr val="phClr">
-                <a:shade val="63000"/>
-                <a:satMod val="120000"/>
-              </a:schemeClr>
-            </a:gs>
-          </a:gsLst>
-          <a:lin ang="5400000" scaled="0"/>
-        </a:gradFill>
-      </a:bgFillStyleLst>
-    </a:fmtScheme>
-  </a:themeElements>
-  <a:objectDefaults/>
-  <a:extraClrSchemeLst/>
-  <a:extLst>
-    <a:ext uri="{05A4C25C-085E-4340-85A3-A5531E510DB2}">
-      <thm15:themeFamily xmlns:thm15="http://schemas.microsoft.com/office/thememl/2012/main" name="Office Theme" id="{62F939B6-93AF-4DB8-9C6B-D6C7DFDC589F}" vid="{4A3C46E8-61CC-4603-A589-7422A47A8E4A}"/>
-    </a:ext>
-  </a:extLst>
-</a:theme>
 </file>
</xml_diff>